<commit_message>
notebook 5 slide improvised
</commit_message>
<xml_diff>
--- a/report/phase1_presentation.pptx
+++ b/report/phase1_presentation.pptx
@@ -8,7 +8,6 @@
     <p:sldId id="256" r:id="rId2"/>
     <p:sldId id="257" r:id="rId3"/>
     <p:sldId id="258" r:id="rId4"/>
-    <p:sldId id="259" r:id="rId5"/>
     <p:sldId id="260" r:id="rId6"/>
     <p:sldId id="261" r:id="rId7"/>
     <p:sldId id="262" r:id="rId8"/>
@@ -862,307 +861,6 @@
 </c:chartSpace>
 </file>
 
-<file path=ppt/charts/chart3.xml><?xml version="1.0" encoding="utf-8"?>
-<c:chartSpace xmlns:c="http://schemas.openxmlformats.org/drawingml/2006/chart" xmlns:a="http://schemas.openxmlformats.org/drawingml/2006/main" xmlns:r="http://schemas.openxmlformats.org/officeDocument/2006/relationships">
-  <c:date1904 val="0"/>
-  <c:roundedCorners val="1"/>
-  <c:chart>
-    <c:title>
-      <c:tx>
-        <c:rich>
-          <a:bodyPr/>
-          <a:lstStyle/>
-          <a:p>
-            <a:pPr>
-              <a:defRPr sz="1200" b="0" i="0" u="none" strike="noStrike">
-                <a:solidFill>
-                  <a:srgbClr val="14213D"/>
-                </a:solidFill>
-                <a:latin typeface="+mn-lt"/>
-              </a:defRPr>
-            </a:pPr>
-            <a:r>
-              <a:rPr sz="1200" b="0" i="0" u="none" strike="noStrike">
-                <a:solidFill>
-                  <a:srgbClr val="14213D"/>
-                </a:solidFill>
-                <a:latin typeface="+mn-lt"/>
-              </a:rPr>
-              <a:t>Real effects answered correctly, of 32</a:t>
-            </a:r>
-          </a:p>
-        </c:rich>
-      </c:tx>
-      <c:layout/>
-      <c:overlay val="0"/>
-    </c:title>
-    <c:autoTitleDeleted val="0"/>
-    <c:plotArea>
-      <c:layout/>
-      <c:barChart>
-        <c:barDir val="col"/>
-        <c:grouping val="clustered"/>
-        <c:varyColors val="0"/>
-        <c:ser>
-          <c:idx val="0"/>
-          <c:order val="0"/>
-          <c:tx>
-            <c:strRef>
-              <c:f>Sheet1!$B$1</c:f>
-              <c:strCache>
-                <c:ptCount val="1"/>
-                <c:pt idx="0">
-                  <c:v>Real effects correct</c:v>
-                </c:pt>
-              </c:strCache>
-            </c:strRef>
-          </c:tx>
-          <c:spPr>
-            <a:solidFill>
-              <a:srgbClr val="E07A1F"/>
-            </a:solidFill>
-            <a:effectLst/>
-          </c:spPr>
-          <c:invertIfNegative val="0"/>
-          <c:dLbls>
-            <c:numFmt formatCode="#,##0" sourceLinked="0"/>
-            <c:txPr>
-              <a:bodyPr/>
-              <a:lstStyle/>
-              <a:p>
-                <a:pPr>
-                  <a:defRPr b="0" i="0" strike="noStrike" sz="1100" u="none">
-                    <a:solidFill>
-                      <a:srgbClr val="1A1F2B"/>
-                    </a:solidFill>
-                    <a:latin typeface="+mn-lt"/>
-                  </a:defRPr>
-                </a:pPr>
-              </a:p>
-            </c:txPr>
-            <c:showLegendKey val="0"/>
-            <c:showVal val="1"/>
-            <c:showCatName val="0"/>
-            <c:showSerName val="0"/>
-            <c:showPercent val="0"/>
-            <c:showBubbleSize val="0"/>
-            <c:showLeaderLines val="0"/>
-          </c:dLbls>
-          <c:dPt>
-            <c:idx val="0"/>
-            <c:invertIfNegative val="0"/>
-            <c:bubble3D val="0"/>
-            <c:spPr>
-              <a:solidFill>
-                <a:srgbClr val="E07A1F"/>
-              </a:solidFill>
-              <a:effectLst/>
-            </c:spPr>
-          </c:dPt>
-          <c:dPt>
-            <c:idx val="1"/>
-            <c:invertIfNegative val="0"/>
-            <c:bubble3D val="0"/>
-            <c:spPr>
-              <a:solidFill>
-                <a:srgbClr val="8D99AE"/>
-              </a:solidFill>
-              <a:effectLst/>
-            </c:spPr>
-          </c:dPt>
-          <c:dPt>
-            <c:idx val="2"/>
-            <c:invertIfNegative val="0"/>
-            <c:bubble3D val="0"/>
-            <c:spPr>
-              <a:solidFill>
-                <a:srgbClr val="8D99AE"/>
-              </a:solidFill>
-              <a:effectLst/>
-            </c:spPr>
-          </c:dPt>
-          <c:cat>
-            <c:multiLvlStrRef>
-              <c:f>Sheet1!$A$2:$A$4</c:f>
-              <c:multiLvlStrCache>
-                <c:ptCount val="3"/>
-                <c:lvl>
-                  <c:pt idx="0">
-                    <c:v>Our DAG</c:v>
-                  </c:pt>
-                  <c:pt idx="1">
-                    <c:v>Arrows reversed</c:v>
-                  </c:pt>
-                  <c:pt idx="2">
-                    <c:v>Empty graph</c:v>
-                  </c:pt>
-                </c:lvl>
-              </c:multiLvlStrCache>
-            </c:multiLvlStrRef>
-          </c:cat>
-          <c:val>
-            <c:numRef>
-              <c:f>Sheet1!$B$2:$B$4</c:f>
-              <c:numCache>
-                <c:formatCode>General</c:formatCode>
-                <c:ptCount val="3"/>
-                <c:pt idx="0">
-                  <c:v>28</c:v>
-                </c:pt>
-                <c:pt idx="1">
-                  <c:v>0</c:v>
-                </c:pt>
-                <c:pt idx="2">
-                  <c:v>0</c:v>
-                </c:pt>
-              </c:numCache>
-            </c:numRef>
-          </c:val>
-        </c:ser>
-        <c:dLbls>
-          <c:numFmt formatCode="#,##0" sourceLinked="0"/>
-          <c:txPr>
-            <a:bodyPr/>
-            <a:lstStyle/>
-            <a:p>
-              <a:pPr>
-                <a:defRPr b="0" i="0" strike="noStrike" sz="1100" u="none">
-                  <a:solidFill>
-                    <a:srgbClr val="1A1F2B"/>
-                  </a:solidFill>
-                  <a:latin typeface="+mn-lt"/>
-                </a:defRPr>
-              </a:pPr>
-            </a:p>
-          </c:txPr>
-          <c:showLegendKey val="0"/>
-          <c:showVal val="1"/>
-          <c:showCatName val="0"/>
-          <c:showSerName val="0"/>
-          <c:showPercent val="0"/>
-          <c:showBubbleSize val="0"/>
-          <c:showLeaderLines val="0"/>
-        </c:dLbls>
-        <c:gapWidth val="150"/>
-        <c:overlap val="0"/>
-        <c:axId val="2094734554"/>
-        <c:axId val="2094734552"/>
-        <c:axId val="2094734556"/>
-      </c:barChart>
-      <c:catAx>
-        <c:axId val="2094734554"/>
-        <c:scaling>
-          <c:orientation val="minMax"/>
-        </c:scaling>
-        <c:delete val="0"/>
-        <c:axPos val="b"/>
-        <c:numFmt formatCode="General" sourceLinked="1"/>
-        <c:majorTickMark val="out"/>
-        <c:minorTickMark val="none"/>
-        <c:tickLblPos val="low"/>
-        <c:spPr>
-          <a:ln w="12700" cap="flat">
-            <a:noFill/>
-            <a:prstDash val="solid"/>
-            <a:round/>
-          </a:ln>
-        </c:spPr>
-        <c:txPr>
-          <a:bodyPr/>
-          <a:lstStyle/>
-          <a:p>
-            <a:pPr>
-              <a:defRPr sz="1100" b="0" i="0" u="none" strike="noStrike">
-                <a:solidFill>
-                  <a:srgbClr val="5C6B8A"/>
-                </a:solidFill>
-                <a:latin typeface="+mn-lt"/>
-              </a:defRPr>
-            </a:pPr>
-            <a:endParaRPr lang="en-US"/>
-          </a:p>
-        </c:txPr>
-        <c:crossAx val="2094734552"/>
-        <c:crosses val="autoZero"/>
-        <c:auto val="1"/>
-        <c:lblAlgn val="ctr"/>
-        <c:noMultiLvlLbl val="1"/>
-      </c:catAx>
-      <c:valAx>
-        <c:axId val="2094734552"/>
-        <c:scaling>
-          <c:orientation val="minMax"/>
-          <c:max val="32"/>
-          <c:min val="0"/>
-        </c:scaling>
-        <c:delete val="0"/>
-        <c:axPos val="l"/>
-        <c:majorGridlines>
-          <c:spPr>
-            <a:ln w="6350" cap="flat">
-              <a:solidFill>
-                <a:srgbClr val="DDE2EA"/>
-              </a:solidFill>
-              <a:prstDash val="solid"/>
-              <a:round/>
-            </a:ln>
-          </c:spPr>
-        </c:majorGridlines>
-        <c:numFmt formatCode="General" sourceLinked="0"/>
-        <c:majorTickMark val="out"/>
-        <c:minorTickMark val="none"/>
-        <c:tickLblPos val="nextTo"/>
-        <c:spPr>
-          <a:ln w="12700" cap="flat">
-            <a:noFill/>
-            <a:prstDash val="solid"/>
-            <a:round/>
-          </a:ln>
-        </c:spPr>
-        <c:txPr>
-          <a:bodyPr/>
-          <a:lstStyle/>
-          <a:p>
-            <a:pPr>
-              <a:defRPr sz="1000" b="0" i="0" u="none" strike="noStrike">
-                <a:solidFill>
-                  <a:srgbClr val="5C6B8A"/>
-                </a:solidFill>
-                <a:latin typeface="+mn-lt"/>
-              </a:defRPr>
-            </a:pPr>
-            <a:endParaRPr lang="en-US"/>
-          </a:p>
-        </c:txPr>
-        <c:crossAx val="2094734554"/>
-        <c:crosses val="autoZero"/>
-        <c:crossBetween val="between"/>
-        <c:majorUnit val="8"/>
-      </c:valAx>
-      <c:spPr>
-        <a:noFill/>
-        <a:ln>
-          <a:noFill/>
-        </a:ln>
-        <a:effectLst/>
-      </c:spPr>
-    </c:plotArea>
-    <c:plotVisOnly val="1"/>
-    <c:dispBlanksAs val="span"/>
-  </c:chart>
-  <c:spPr>
-    <a:noFill/>
-    <a:ln>
-      <a:noFill/>
-    </a:ln>
-    <a:effectLst/>
-  </c:spPr>
-  <c:externalData r:id="rId1">
-    <c:autoUpdate val="0"/>
-  </c:externalData>
-</c:chartSpace>
-</file>
-
 <file path=ppt/notesMasters/notesMaster1.xml><?xml version="1.0" encoding="utf-8"?>
 <p:notesMaster xmlns:a="http://schemas.openxmlformats.org/drawingml/2006/main" xmlns:r="http://schemas.openxmlformats.org/officeDocument/2006/relationships" xmlns:p="http://schemas.openxmlformats.org/presentationml/2006/main">
   <p:cSld>
@@ -1998,7 +1696,7 @@
           <a:p>
             <a:r>
               <a:rPr lang="en-US" dirty="0"/>
-              <a:t>Presenter: Jagruthi. do(X) forces X and cuts the arrows into it. Chain A-&gt;B-&gt;C: true effect of A on C 0.490, our graph 0.498, reversed graph 0.000. The 4 misses come from one premise where the model left out C-&gt;D and C-&gt;E, edges PC says are certain but the dataset labels 0. The old check had a 0.05 tolerance that a 0.046 effect could pass with no arrow; requiring the path to match fixes that.</a:t>
+              <a:t>Presenter: Jagruthi. A Bayesian network is a DAG where every node has a probability table: the chance it is 1 given its parents. Corr2Cause is only text, so there are no numbers to learn from. We take the test premises where PC knows the full graph (only one DAG fits, 5 premises), give that true graph random tables, and simulate 5,000 rows of 0/1. Then pgmpy fits our predicted DAG, and the same DAG with all arrows reversed, on those rows. do(X) means we set X ourselves, which cuts the arrows into X; this is different from just observing X. Effect = P(Y=1 | do(X=1)) minus P(Y=1 | do(X=0)). Chain example: the true effect of A on C is 0.490 and our graph gives 0.498; the reversed graph gives 0.000 and wrongly says C affects A (0.514). On the test graphs we ask every ordered pair: 96 queries, 32 with a real effect. Our DAG gets 28 of 32; reversed and empty graphs get 0. </a:t>
             </a:r>
             <a:endParaRPr lang="en-US" dirty="0"/>
           </a:p>
@@ -2286,94 +1984,6 @@
             <a:fld id="{F7021451-1387-4CA6-816F-3879F97B5CBC}" type="slidenum">
               <a:rPr lang="en-US"/>
               <a:t>3</a:t>
-            </a:fld>
-            <a:endParaRPr lang="en-US"/>
-          </a:p>
-        </p:txBody>
-      </p:sp>
-    </p:spTree>
-    <p:extLst>
-      <p:ext uri="{BB962C8B-B14F-4D97-AF65-F5344CB8AC3E}">
-        <p14:creationId xmlns:p14="http://schemas.microsoft.com/office/powerpoint/2010/main" val="1024086991"/>
-      </p:ext>
-    </p:extLst>
-  </p:cSld>
-  <p:clrMapOvr>
-    <a:masterClrMapping/>
-  </p:clrMapOvr>
-</p:notes>
-</file>
-
-<file path=ppt/notesSlides/notesSlide4.xml><?xml version="1.0" encoding="utf-8"?>
-<p:notes xmlns:a="http://schemas.openxmlformats.org/drawingml/2006/main" xmlns:r="http://schemas.openxmlformats.org/officeDocument/2006/relationships" xmlns:p="http://schemas.openxmlformats.org/presentationml/2006/main">
-  <p:cSld>
-    <p:spTree>
-      <p:nvGrpSpPr>
-        <p:cNvPr id="1" name=""/>
-        <p:cNvGrpSpPr/>
-        <p:nvPr/>
-      </p:nvGrpSpPr>
-      <p:grpSpPr>
-        <a:xfrm>
-          <a:off x="0" y="0"/>
-          <a:ext cx="0" cy="0"/>
-          <a:chOff x="0" y="0"/>
-          <a:chExt cx="0" cy="0"/>
-        </a:xfrm>
-      </p:grpSpPr>
-      <p:sp>
-        <p:nvSpPr>
-          <p:cNvPr id="2" name="Slide Image Placeholder 1"/>
-          <p:cNvSpPr>
-            <a:spLocks noGrp="1" noRot="1" noChangeAspect="1"/>
-          </p:cNvSpPr>
-          <p:nvPr>
-            <p:ph type="sldImg"/>
-          </p:nvPr>
-        </p:nvSpPr>
-        <p:spPr/>
-      </p:sp>
-      <p:sp>
-        <p:nvSpPr>
-          <p:cNvPr id="3" name="Notes Placeholder 2"/>
-          <p:cNvSpPr>
-            <a:spLocks noGrp="1"/>
-          </p:cNvSpPr>
-          <p:nvPr>
-            <p:ph type="body" idx="1"/>
-          </p:nvPr>
-        </p:nvSpPr>
-        <p:spPr/>
-        <p:txBody>
-          <a:bodyPr/>
-          <a:lstStyle/>
-          <a:p>
-            <a:r>
-              <a:rPr lang="en-US" dirty="0"/>
-              <a:t>These four numbers summarise the project: the symbolic step explains almost all labels, the final classifier is strong and its uncertainty is reported, the graphs it draws are mostly right, and the graphs answer what-if questions where simple baselines fail.</a:t>
-            </a:r>
-            <a:endParaRPr lang="en-US" dirty="0"/>
-          </a:p>
-        </p:txBody>
-      </p:sp>
-      <p:sp>
-        <p:nvSpPr>
-          <p:cNvPr id="4" name="Slide Number Placeholder 3"/>
-          <p:cNvSpPr>
-            <a:spLocks noGrp="1"/>
-          </p:cNvSpPr>
-          <p:nvPr>
-            <p:ph type="sldNum" sz="quarter" idx="10"/>
-          </p:nvPr>
-        </p:nvSpPr>
-        <p:spPr/>
-        <p:txBody>
-          <a:bodyPr/>
-          <a:lstStyle/>
-          <a:p>
-            <a:fld id="{F7021451-1387-4CA6-816F-3879F97B5CBC}" type="slidenum">
-              <a:rPr lang="en-US"/>
-              <a:t>4</a:t>
             </a:fld>
             <a:endParaRPr lang="en-US"/>
           </a:p>
@@ -7607,7 +7217,7 @@
                   <a:schemeClr val="tx2"/>
                 </a:solidFill>
               </a:rPr>
-              <a:t>Asking “what if” with do(X)</a:t>
+              <a:t>Asking “what if” with a Bayesian network</a:t>
             </a:r>
             <a:endParaRPr lang="en-US" sz="2600" dirty="0"/>
           </a:p>
@@ -7615,41 +7225,38 @@
       </p:sp>
       <p:sp>
         <p:nvSpPr>
-          <p:cNvPr id="4" name="card-121"/>
+          <p:cNvPr id="11" name="formula-card-11"/>
           <p:cNvSpPr/>
           <p:nvPr/>
         </p:nvSpPr>
         <p:spPr>
           <a:xfrm>
-            <a:off x="457200" y="1234440"/>
-            <a:ext cx="3931920" cy="960120"/>
+            <a:off x="457200" y="1024128"/>
+            <a:ext cx="8229600" cy="914400"/>
           </a:xfrm>
           <a:prstGeom prst="roundRect">
             <a:avLst>
-              <a:gd name="adj" fmla="val 7619"/>
+              <a:gd name="adj" fmla="val 8000"/>
             </a:avLst>
           </a:prstGeom>
           <a:solidFill>
             <a:schemeClr val="bg2"/>
           </a:solidFill>
-          <a:ln w="12700">
-            <a:solidFill>
-              <a:schemeClr val="bg2"/>
-            </a:solidFill>
-            <a:prstDash val="solid"/>
+          <a:ln>
+            <a:noFill/>
           </a:ln>
         </p:spPr>
       </p:sp>
       <p:sp>
         <p:nvSpPr>
-          <p:cNvPr id="5" name="text-122"/>
+          <p:cNvPr id="12" name="formula-12"/>
           <p:cNvSpPr txBox="1"/>
           <p:nvPr/>
         </p:nvSpPr>
         <p:spPr>
           <a:xfrm>
-            <a:off x="640080" y="1344168"/>
-            <a:ext cx="3566160" cy="777240"/>
+            <a:off x="640080" y="1115568"/>
+            <a:ext cx="3931920" cy="292608"/>
           </a:xfrm>
           <a:prstGeom prst="rect">
             <a:avLst/>
@@ -7661,45 +7268,62 @@
           <a:bodyPr wrap="square" lIns="0" tIns="0" rIns="0" bIns="0" rtlCol="0" anchor="t"/>
           <a:lstStyle/>
           <a:p>
-            <a:pPr indent="0" marL="0">
-              <a:buNone/>
-            </a:pPr>
-            <a:r>
-              <a:rPr lang="en-US" sz="1400" b="1" dirty="0">
+            <a:pPr algn="l" indent="0" marL="0">
+              <a:buNone/>
+            </a:pPr>
+            <a:r>
+              <a:rPr lang="en-US" sz="1500" b="1" dirty="0">
+                <a:solidFill>
+                  <a:schemeClr val="accent2"/>
+                </a:solidFill>
+              </a:rPr>
+              <a:t>effect</a:t>
+            </a:r>
+            <a:r>
+              <a:rPr lang="en-US" sz="1500" b="1" dirty="0">
                 <a:solidFill>
                   <a:schemeClr val="tx2"/>
                 </a:solidFill>
               </a:rPr>
-              <a:t>ACE = P(Y=1 | do(X=1)) − P(Y=1 | do(X=0))</a:t>
-            </a:r>
-            <a:endParaRPr lang="en-US" sz="1400" dirty="0"/>
-          </a:p>
-          <a:p>
-            <a:pPr indent="0" marL="0">
-              <a:buNone/>
-            </a:pPr>
-            <a:r>
-              <a:rPr lang="en-US" sz="1200" dirty="0">
-                <a:solidFill>
-                  <a:schemeClr val="accent5"/>
-                </a:solidFill>
-              </a:rPr>
-              <a:t>Simulate 5,000 rows from the true graph, fit our DAG with pgmpy, compare the effects</a:t>
-            </a:r>
-            <a:endParaRPr lang="en-US" sz="1400" dirty="0"/>
-          </a:p>
-        </p:txBody>
-      </p:sp>
-      <p:sp>
-        <p:nvSpPr>
-          <p:cNvPr id="6" name="bullets-123"/>
+              <a:t>  =  </a:t>
+            </a:r>
+            <a:r>
+              <a:rPr lang="en-US" sz="1500" b="1" dirty="0">
+                <a:solidFill>
+                  <a:schemeClr val="tx2"/>
+                </a:solidFill>
+              </a:rPr>
+              <a:t>P(Y=1 | do(X=1))</a:t>
+            </a:r>
+            <a:r>
+              <a:rPr lang="en-US" sz="1500" b="1" dirty="0">
+                <a:solidFill>
+                  <a:schemeClr val="tx2"/>
+                </a:solidFill>
+              </a:rPr>
+              <a:t>  −  </a:t>
+            </a:r>
+            <a:r>
+              <a:rPr lang="en-US" sz="1500" b="1" dirty="0">
+                <a:solidFill>
+                  <a:schemeClr val="tx2"/>
+                </a:solidFill>
+              </a:rPr>
+              <a:t>P(Y=1 | do(X=0))</a:t>
+            </a:r>
+          </a:p>
+        </p:txBody>
+      </p:sp>
+      <p:sp>
+        <p:nvSpPr>
+          <p:cNvPr id="13" name="do-note-13"/>
           <p:cNvSpPr txBox="1"/>
           <p:nvPr/>
         </p:nvSpPr>
         <p:spPr>
           <a:xfrm>
-            <a:off x="457200" y="2468880"/>
-            <a:ext cx="3931920" cy="1920240"/>
+            <a:off x="640080" y="1481328"/>
+            <a:ext cx="3749040" cy="384048"/>
           </a:xfrm>
           <a:prstGeom prst="rect">
             <a:avLst/>
@@ -7711,87 +7335,46 @@
           <a:bodyPr wrap="square" lIns="0" tIns="0" rIns="0" bIns="0" rtlCol="0" anchor="t"/>
           <a:lstStyle/>
           <a:p>
-            <a:pPr marL="177800" indent="-177800">
-              <a:spcAft>
-                <a:spcPts val="600"/>
-              </a:spcAft>
-              <a:buSzPct val="100000"/>
-              <a:buChar char="•"/>
-            </a:pPr>
-            <a:r>
-              <a:rPr lang="en-US" sz="1300" dirty="0">
-                <a:solidFill>
-                  <a:schemeClr val="tx1"/>
-                </a:solidFill>
-              </a:rPr>
-              <a:t>5 fully known test graphs, each with its own random probabilities</a:t>
-            </a:r>
-            <a:endParaRPr lang="en-US" sz="1300" dirty="0"/>
-          </a:p>
-          <a:p>
-            <a:pPr marL="177800" indent="-177800">
-              <a:spcAft>
-                <a:spcPts val="600"/>
-              </a:spcAft>
-              <a:buSzPct val="100000"/>
-              <a:buChar char="•"/>
-            </a:pPr>
-            <a:r>
-              <a:rPr lang="en-US" sz="1300" dirty="0">
-                <a:solidFill>
-                  <a:schemeClr val="tx1"/>
-                </a:solidFill>
-              </a:rPr>
-              <a:t>Every ordered pair, both directions: 96 queries, 32 with a real effect</a:t>
-            </a:r>
-            <a:endParaRPr lang="en-US" sz="1300" dirty="0"/>
-          </a:p>
-          <a:p>
-            <a:pPr marL="177800" indent="-177800">
-              <a:spcAft>
-                <a:spcPts val="600"/>
-              </a:spcAft>
-              <a:buSzPct val="100000"/>
-              <a:buChar char="•"/>
-            </a:pPr>
-            <a:r>
-              <a:rPr lang="en-US" sz="1300" dirty="0">
-                <a:solidFill>
-                  <a:schemeClr val="tx1"/>
-                </a:solidFill>
-              </a:rPr>
-              <a:t>Correct only if the graph gets “is there an effect?” and its size within 0.05</a:t>
-            </a:r>
-            <a:endParaRPr lang="en-US" sz="1300" dirty="0"/>
-          </a:p>
-        </p:txBody>
-      </p:sp>
-      <p:graphicFrame>
-        <p:nvGraphicFramePr>
-          <p:cNvPr id="7" name="chart-124" descr=""/>
-          <p:cNvGraphicFramePr/>
-          <p:nvPr/>
-        </p:nvGraphicFramePr>
-        <p:xfrm>
-          <a:off x="4663440" y="1188720"/>
-          <a:ext cx="4023360" cy="2514600"/>
-        </p:xfrm>
-        <a:graphic xmlns:a="http://schemas.openxmlformats.org/drawingml/2006/main">
-          <a:graphicData uri="http://schemas.openxmlformats.org/drawingml/2006/chart">
-            <c:chart xmlns:c="http://schemas.openxmlformats.org/drawingml/2006/chart" r:id="rId1"/>
-          </a:graphicData>
-        </a:graphic>
-      </p:graphicFrame>
-      <p:sp>
-        <p:nvSpPr>
-          <p:cNvPr id="8" name="text-125"/>
+            <a:pPr algn="l" indent="0" marL="0">
+              <a:buNone/>
+            </a:pPr>
+            <a:r>
+              <a:rPr lang="en-US" sz="1050" dirty="0">
+                <a:solidFill>
+                  <a:schemeClr val="accent5"/>
+                </a:solidFill>
+              </a:rPr>
+              <a:t>do(X) means we </a:t>
+            </a:r>
+            <a:r>
+              <a:rPr lang="en-US" sz="1050" b="1" dirty="0">
+                <a:solidFill>
+                  <a:schemeClr val="accent5"/>
+                </a:solidFill>
+              </a:rPr>
+              <a:t>set</a:t>
+            </a:r>
+            <a:r>
+              <a:rPr lang="en-US" sz="1050" dirty="0">
+                <a:solidFill>
+                  <a:schemeClr val="accent5"/>
+                </a:solidFill>
+              </a:rPr>
+              <a:t> X ourselves and cut the arrows into X. It is not the same as just seeing X.</a:t>
+            </a:r>
+          </a:p>
+        </p:txBody>
+      </p:sp>
+      <p:sp>
+        <p:nvSpPr>
+          <p:cNvPr id="14" name="term-14"/>
           <p:cNvSpPr txBox="1"/>
           <p:nvPr/>
         </p:nvSpPr>
         <p:spPr>
           <a:xfrm>
-            <a:off x="4663440" y="3794760"/>
-            <a:ext cx="4023360" cy="640080"/>
+            <a:off x="4709160" y="1133856"/>
+            <a:ext cx="3840480" cy="237744"/>
           </a:xfrm>
           <a:prstGeom prst="rect">
             <a:avLst/>
@@ -7803,18 +7386,1446 @@
           <a:bodyPr wrap="square" lIns="0" tIns="0" rIns="0" bIns="0" rtlCol="0" anchor="t"/>
           <a:lstStyle/>
           <a:p>
-            <a:pPr indent="0" marL="0">
-              <a:buNone/>
-            </a:pPr>
-            <a:r>
-              <a:rPr lang="en-US" sz="1200" dirty="0">
+            <a:pPr algn="l" indent="0" marL="0">
+              <a:buNone/>
+            </a:pPr>
+            <a:r>
+              <a:rPr lang="en-US" sz="1050" b="1" dirty="0">
+                <a:solidFill>
+                  <a:schemeClr val="tx2"/>
+                </a:solidFill>
+              </a:rPr>
+              <a:t>P(Y=1 | do(X=1))</a:t>
+            </a:r>
+            <a:r>
+              <a:rPr lang="en-US" sz="1050" dirty="0">
+                <a:solidFill>
+                  <a:schemeClr val="tx1"/>
+                </a:solidFill>
+              </a:rPr>
+              <a:t>  chance that Y is 1 when we force X to 1</a:t>
+            </a:r>
+          </a:p>
+        </p:txBody>
+      </p:sp>
+      <p:sp>
+        <p:nvSpPr>
+          <p:cNvPr id="15" name="term-15"/>
+          <p:cNvSpPr txBox="1"/>
+          <p:nvPr/>
+        </p:nvSpPr>
+        <p:spPr>
+          <a:xfrm>
+            <a:off x="4709160" y="1380744"/>
+            <a:ext cx="3840480" cy="237744"/>
+          </a:xfrm>
+          <a:prstGeom prst="rect">
+            <a:avLst/>
+          </a:prstGeom>
+          <a:noFill/>
+          <a:ln/>
+        </p:spPr>
+        <p:txBody>
+          <a:bodyPr wrap="square" lIns="0" tIns="0" rIns="0" bIns="0" rtlCol="0" anchor="t"/>
+          <a:lstStyle/>
+          <a:p>
+            <a:pPr algn="l" indent="0" marL="0">
+              <a:buNone/>
+            </a:pPr>
+            <a:r>
+              <a:rPr lang="en-US" sz="1050" b="1" dirty="0">
+                <a:solidFill>
+                  <a:schemeClr val="tx2"/>
+                </a:solidFill>
+              </a:rPr>
+              <a:t>P(Y=1 | do(X=0))</a:t>
+            </a:r>
+            <a:r>
+              <a:rPr lang="en-US" sz="1050" dirty="0">
+                <a:solidFill>
+                  <a:schemeClr val="tx1"/>
+                </a:solidFill>
+              </a:rPr>
+              <a:t>  chance that Y is 1 when we force X to 0</a:t>
+            </a:r>
+          </a:p>
+        </p:txBody>
+      </p:sp>
+      <p:sp>
+        <p:nvSpPr>
+          <p:cNvPr id="16" name="term-16"/>
+          <p:cNvSpPr txBox="1"/>
+          <p:nvPr/>
+        </p:nvSpPr>
+        <p:spPr>
+          <a:xfrm>
+            <a:off x="4709160" y="1627632"/>
+            <a:ext cx="3840480" cy="237744"/>
+          </a:xfrm>
+          <a:prstGeom prst="rect">
+            <a:avLst/>
+          </a:prstGeom>
+          <a:noFill/>
+          <a:ln/>
+        </p:spPr>
+        <p:txBody>
+          <a:bodyPr wrap="square" lIns="0" tIns="0" rIns="0" bIns="0" rtlCol="0" anchor="t"/>
+          <a:lstStyle/>
+          <a:p>
+            <a:pPr algn="l" indent="0" marL="0">
+              <a:buNone/>
+            </a:pPr>
+            <a:r>
+              <a:rPr lang="en-US" sz="1050" b="1" dirty="0">
+                <a:solidFill>
+                  <a:schemeClr val="tx2"/>
+                </a:solidFill>
+              </a:rPr>
+              <a:t>effect</a:t>
+            </a:r>
+            <a:r>
+              <a:rPr lang="en-US" sz="1050" dirty="0">
+                <a:solidFill>
+                  <a:schemeClr val="tx1"/>
+                </a:solidFill>
+              </a:rPr>
+              <a:t>  the gap: how much X changes Y. 0 means no effect</a:t>
+            </a:r>
+          </a:p>
+        </p:txBody>
+      </p:sp>
+      <p:sp>
+        <p:nvSpPr>
+          <p:cNvPr id="17" name="step-17"/>
+          <p:cNvSpPr/>
+          <p:nvPr/>
+        </p:nvSpPr>
+        <p:spPr>
+          <a:xfrm>
+            <a:off x="457200" y="2103120"/>
+            <a:ext cx="310896" cy="310896"/>
+          </a:xfrm>
+          <a:prstGeom prst="ellipse">
+            <a:avLst/>
+          </a:prstGeom>
+          <a:solidFill>
+            <a:schemeClr val="accent1"/>
+          </a:solidFill>
+          <a:ln>
+            <a:noFill/>
+          </a:ln>
+        </p:spPr>
+        <p:txBody>
+          <a:bodyPr wrap="none" lIns="0" tIns="0" rIns="0" bIns="0" rtlCol="0" anchor="ctr"/>
+          <a:lstStyle/>
+          <a:p>
+            <a:pPr algn="ctr" indent="0" marL="0">
+              <a:buNone/>
+            </a:pPr>
+            <a:r>
+              <a:rPr lang="en-US" sz="1200" b="1" dirty="0">
+                <a:solidFill>
+                  <a:schemeClr val="bg1"/>
+                </a:solidFill>
+              </a:rPr>
+              <a:t>1</a:t>
+            </a:r>
+          </a:p>
+        </p:txBody>
+      </p:sp>
+      <p:sp>
+        <p:nvSpPr>
+          <p:cNvPr id="18" name="step-text-18"/>
+          <p:cNvSpPr txBox="1"/>
+          <p:nvPr/>
+        </p:nvSpPr>
+        <p:spPr>
+          <a:xfrm>
+            <a:off x="896112" y="2084832"/>
+            <a:ext cx="3429000" cy="640080"/>
+          </a:xfrm>
+          <a:prstGeom prst="rect">
+            <a:avLst/>
+          </a:prstGeom>
+          <a:noFill/>
+          <a:ln/>
+        </p:spPr>
+        <p:txBody>
+          <a:bodyPr wrap="square" lIns="0" tIns="0" rIns="0" bIns="0" rtlCol="0" anchor="t"/>
+          <a:lstStyle/>
+          <a:p>
+            <a:pPr algn="l" indent="0" marL="0">
+              <a:buNone/>
+            </a:pPr>
+            <a:r>
+              <a:rPr lang="en-US" sz="1250" b="1" dirty="0">
+                <a:solidFill>
+                  <a:schemeClr val="tx2"/>
+                </a:solidFill>
+              </a:rPr>
+              <a:t>Simulate data</a:t>
+            </a:r>
+          </a:p>
+          <a:p>
+            <a:pPr algn="l" indent="0" marL="0">
+              <a:buNone/>
+            </a:pPr>
+            <a:r>
+              <a:rPr lang="en-US" sz="1050" dirty="0">
                 <a:solidFill>
                   <a:schemeClr val="accent5"/>
                 </a:solidFill>
               </a:rPr>
-              <a:t>All queries: 92 / 96 vs 36 / 96 and 64 / 96. Mean error 0.011 vs 0.126 and 0.064.</a:t>
-            </a:r>
-            <a:endParaRPr lang="en-US" sz="1200" dirty="0"/>
+              <a:t>Corr2Cause has no numbers, so we give a fully known test graph random tables P(node = 1 | parents) and draw 5,000 rows of 0/1.</a:t>
+            </a:r>
+          </a:p>
+        </p:txBody>
+      </p:sp>
+      <p:sp>
+        <p:nvSpPr>
+          <p:cNvPr id="19" name="step-19"/>
+          <p:cNvSpPr/>
+          <p:nvPr/>
+        </p:nvSpPr>
+        <p:spPr>
+          <a:xfrm>
+            <a:off x="457200" y="2816352"/>
+            <a:ext cx="310896" cy="310896"/>
+          </a:xfrm>
+          <a:prstGeom prst="ellipse">
+            <a:avLst/>
+          </a:prstGeom>
+          <a:solidFill>
+            <a:schemeClr val="accent1"/>
+          </a:solidFill>
+          <a:ln>
+            <a:noFill/>
+          </a:ln>
+        </p:spPr>
+        <p:txBody>
+          <a:bodyPr wrap="none" lIns="0" tIns="0" rIns="0" bIns="0" rtlCol="0" anchor="ctr"/>
+          <a:lstStyle/>
+          <a:p>
+            <a:pPr algn="ctr" indent="0" marL="0">
+              <a:buNone/>
+            </a:pPr>
+            <a:r>
+              <a:rPr lang="en-US" sz="1200" b="1" dirty="0">
+                <a:solidFill>
+                  <a:schemeClr val="bg1"/>
+                </a:solidFill>
+              </a:rPr>
+              <a:t>2</a:t>
+            </a:r>
+          </a:p>
+        </p:txBody>
+      </p:sp>
+      <p:sp>
+        <p:nvSpPr>
+          <p:cNvPr id="20" name="step-text-20"/>
+          <p:cNvSpPr txBox="1"/>
+          <p:nvPr/>
+        </p:nvSpPr>
+        <p:spPr>
+          <a:xfrm>
+            <a:off x="896112" y="2798064"/>
+            <a:ext cx="3429000" cy="640080"/>
+          </a:xfrm>
+          <a:prstGeom prst="rect">
+            <a:avLst/>
+          </a:prstGeom>
+          <a:noFill/>
+          <a:ln/>
+        </p:spPr>
+        <p:txBody>
+          <a:bodyPr wrap="square" lIns="0" tIns="0" rIns="0" bIns="0" rtlCol="0" anchor="t"/>
+          <a:lstStyle/>
+          <a:p>
+            <a:pPr algn="l" indent="0" marL="0">
+              <a:buNone/>
+            </a:pPr>
+            <a:r>
+              <a:rPr lang="en-US" sz="1250" b="1" dirty="0">
+                <a:solidFill>
+                  <a:schemeClr val="tx2"/>
+                </a:solidFill>
+              </a:rPr>
+              <a:t>Fit with pgmpy</a:t>
+            </a:r>
+          </a:p>
+          <a:p>
+            <a:pPr algn="l" indent="0" marL="0">
+              <a:buNone/>
+            </a:pPr>
+            <a:r>
+              <a:rPr lang="en-US" sz="1050" dirty="0">
+                <a:solidFill>
+                  <a:schemeClr val="accent5"/>
+                </a:solidFill>
+              </a:rPr>
+              <a:t>pgmpy learns the tables of our predicted DAG, and of the same DAG with every arrow reversed, from the same 5,000 rows.</a:t>
+            </a:r>
+          </a:p>
+        </p:txBody>
+      </p:sp>
+      <p:sp>
+        <p:nvSpPr>
+          <p:cNvPr id="21" name="step-21"/>
+          <p:cNvSpPr/>
+          <p:nvPr/>
+        </p:nvSpPr>
+        <p:spPr>
+          <a:xfrm>
+            <a:off x="457200" y="3529584"/>
+            <a:ext cx="310896" cy="310896"/>
+          </a:xfrm>
+          <a:prstGeom prst="ellipse">
+            <a:avLst/>
+          </a:prstGeom>
+          <a:solidFill>
+            <a:schemeClr val="accent1"/>
+          </a:solidFill>
+          <a:ln>
+            <a:noFill/>
+          </a:ln>
+        </p:spPr>
+        <p:txBody>
+          <a:bodyPr wrap="none" lIns="0" tIns="0" rIns="0" bIns="0" rtlCol="0" anchor="ctr"/>
+          <a:lstStyle/>
+          <a:p>
+            <a:pPr algn="ctr" indent="0" marL="0">
+              <a:buNone/>
+            </a:pPr>
+            <a:r>
+              <a:rPr lang="en-US" sz="1200" b="1" dirty="0">
+                <a:solidFill>
+                  <a:schemeClr val="bg1"/>
+                </a:solidFill>
+              </a:rPr>
+              <a:t>3</a:t>
+            </a:r>
+          </a:p>
+        </p:txBody>
+      </p:sp>
+      <p:sp>
+        <p:nvSpPr>
+          <p:cNvPr id="22" name="step-text-22"/>
+          <p:cNvSpPr txBox="1"/>
+          <p:nvPr/>
+        </p:nvSpPr>
+        <p:spPr>
+          <a:xfrm>
+            <a:off x="896112" y="3511296"/>
+            <a:ext cx="3429000" cy="640080"/>
+          </a:xfrm>
+          <a:prstGeom prst="rect">
+            <a:avLst/>
+          </a:prstGeom>
+          <a:noFill/>
+          <a:ln/>
+        </p:spPr>
+        <p:txBody>
+          <a:bodyPr wrap="square" lIns="0" tIns="0" rIns="0" bIns="0" rtlCol="0" anchor="t"/>
+          <a:lstStyle/>
+          <a:p>
+            <a:pPr algn="l" indent="0" marL="0">
+              <a:buNone/>
+            </a:pPr>
+            <a:r>
+              <a:rPr lang="en-US" sz="1250" b="1" dirty="0">
+                <a:solidFill>
+                  <a:schemeClr val="tx2"/>
+                </a:solidFill>
+              </a:rPr>
+              <a:t>Intervene and compare</a:t>
+            </a:r>
+          </a:p>
+          <a:p>
+            <a:pPr algn="l" indent="0" marL="0">
+              <a:buNone/>
+            </a:pPr>
+            <a:r>
+              <a:rPr lang="en-US" sz="1050" dirty="0">
+                <a:solidFill>
+                  <a:schemeClr val="accent5"/>
+                </a:solidFill>
+              </a:rPr>
+              <a:t>Ask do(X) on Y for every pair of variables and compare each graph's effect with the true effect.</a:t>
+            </a:r>
+          </a:p>
+        </p:txBody>
+      </p:sp>
+      <p:sp>
+        <p:nvSpPr>
+          <p:cNvPr id="23" name="chain-title-23"/>
+          <p:cNvSpPr txBox="1"/>
+          <p:nvPr/>
+        </p:nvSpPr>
+        <p:spPr>
+          <a:xfrm>
+            <a:off x="4434840" y="2066544"/>
+            <a:ext cx="4251960" cy="237744"/>
+          </a:xfrm>
+          <a:prstGeom prst="rect">
+            <a:avLst/>
+          </a:prstGeom>
+          <a:noFill/>
+          <a:ln/>
+        </p:spPr>
+        <p:txBody>
+          <a:bodyPr wrap="square" lIns="0" tIns="0" rIns="0" bIns="0" rtlCol="0" anchor="t"/>
+          <a:lstStyle/>
+          <a:p>
+            <a:pPr algn="l" indent="0" marL="0">
+              <a:buNone/>
+            </a:pPr>
+            <a:r>
+              <a:rPr lang="en-US" sz="1200" b="1" dirty="0">
+                <a:solidFill>
+                  <a:schemeClr val="tx2"/>
+                </a:solidFill>
+              </a:rPr>
+              <a:t>Why direction matters: true graph A → B → C</a:t>
+            </a:r>
+          </a:p>
+        </p:txBody>
+      </p:sp>
+      <p:sp>
+        <p:nvSpPr>
+          <p:cNvPr id="24" name="text-24"/>
+          <p:cNvSpPr txBox="1"/>
+          <p:nvPr/>
+        </p:nvSpPr>
+        <p:spPr>
+          <a:xfrm>
+            <a:off x="7040880" y="2377440"/>
+            <a:ext cx="777240" cy="201168"/>
+          </a:xfrm>
+          <a:prstGeom prst="rect">
+            <a:avLst/>
+          </a:prstGeom>
+          <a:noFill/>
+          <a:ln/>
+        </p:spPr>
+        <p:txBody>
+          <a:bodyPr wrap="square" lIns="0" tIns="0" rIns="0" bIns="0" rtlCol="0" anchor="t"/>
+          <a:lstStyle/>
+          <a:p>
+            <a:pPr algn="ctr" indent="0" marL="0">
+              <a:buNone/>
+            </a:pPr>
+            <a:r>
+              <a:rPr lang="en-US" sz="950" b="1" dirty="0">
+                <a:solidFill>
+                  <a:schemeClr val="accent3"/>
+                </a:solidFill>
+              </a:rPr>
+              <a:t>do(A) on C</a:t>
+            </a:r>
+          </a:p>
+        </p:txBody>
+      </p:sp>
+      <p:sp>
+        <p:nvSpPr>
+          <p:cNvPr id="25" name="text-25"/>
+          <p:cNvSpPr txBox="1"/>
+          <p:nvPr/>
+        </p:nvSpPr>
+        <p:spPr>
+          <a:xfrm>
+            <a:off x="7863840" y="2377440"/>
+            <a:ext cx="777240" cy="201168"/>
+          </a:xfrm>
+          <a:prstGeom prst="rect">
+            <a:avLst/>
+          </a:prstGeom>
+          <a:noFill/>
+          <a:ln/>
+        </p:spPr>
+        <p:txBody>
+          <a:bodyPr wrap="square" lIns="0" tIns="0" rIns="0" bIns="0" rtlCol="0" anchor="t"/>
+          <a:lstStyle/>
+          <a:p>
+            <a:pPr algn="ctr" indent="0" marL="0">
+              <a:buNone/>
+            </a:pPr>
+            <a:r>
+              <a:rPr lang="en-US" sz="950" b="1" dirty="0">
+                <a:solidFill>
+                  <a:schemeClr val="accent3"/>
+                </a:solidFill>
+              </a:rPr>
+              <a:t>do(C) on A</a:t>
+            </a:r>
+          </a:p>
+        </p:txBody>
+      </p:sp>
+      <p:sp>
+        <p:nvSpPr>
+          <p:cNvPr id="26" name="row-26"/>
+          <p:cNvSpPr/>
+          <p:nvPr/>
+        </p:nvSpPr>
+        <p:spPr>
+          <a:xfrm>
+            <a:off x="4434840" y="2615184"/>
+            <a:ext cx="4251960" cy="347472"/>
+          </a:xfrm>
+          <a:prstGeom prst="roundRect">
+            <a:avLst>
+              <a:gd name="adj" fmla="val 12000"/>
+            </a:avLst>
+          </a:prstGeom>
+          <a:solidFill>
+            <a:schemeClr val="bg2"/>
+          </a:solidFill>
+          <a:ln>
+            <a:noFill/>
+          </a:ln>
+        </p:spPr>
+      </p:sp>
+      <p:sp>
+        <p:nvSpPr>
+          <p:cNvPr id="27" name="text-27"/>
+          <p:cNvSpPr txBox="1"/>
+          <p:nvPr/>
+        </p:nvSpPr>
+        <p:spPr>
+          <a:xfrm>
+            <a:off x="4544568" y="2651760"/>
+            <a:ext cx="1143000" cy="274320"/>
+          </a:xfrm>
+          <a:prstGeom prst="rect">
+            <a:avLst/>
+          </a:prstGeom>
+          <a:noFill/>
+          <a:ln/>
+        </p:spPr>
+        <p:txBody>
+          <a:bodyPr wrap="square" lIns="0" tIns="0" rIns="0" bIns="0" rtlCol="0" anchor="ctr"/>
+          <a:lstStyle/>
+          <a:p>
+            <a:pPr algn="l" indent="0" marL="0">
+              <a:buNone/>
+            </a:pPr>
+            <a:r>
+              <a:rPr lang="en-US" sz="1050" b="1" dirty="0">
+                <a:solidFill>
+                  <a:schemeClr val="tx2"/>
+                </a:solidFill>
+              </a:rPr>
+              <a:t>True graph</a:t>
+            </a:r>
+          </a:p>
+        </p:txBody>
+      </p:sp>
+      <p:sp>
+        <p:nvSpPr>
+          <p:cNvPr id="28" name="node-28"/>
+          <p:cNvSpPr/>
+          <p:nvPr/>
+        </p:nvSpPr>
+        <p:spPr>
+          <a:xfrm>
+            <a:off x="5715000" y="2651760"/>
+            <a:ext cx="274320" cy="274320"/>
+          </a:xfrm>
+          <a:prstGeom prst="ellipse">
+            <a:avLst/>
+          </a:prstGeom>
+          <a:solidFill>
+            <a:schemeClr val="tx2"/>
+          </a:solidFill>
+          <a:ln>
+            <a:noFill/>
+          </a:ln>
+        </p:spPr>
+        <p:txBody>
+          <a:bodyPr wrap="none" lIns="0" tIns="0" rIns="0" bIns="0" rtlCol="0" anchor="ctr"/>
+          <a:lstStyle/>
+          <a:p>
+            <a:pPr algn="ctr" indent="0" marL="0">
+              <a:buNone/>
+            </a:pPr>
+            <a:r>
+              <a:rPr lang="en-US" sz="1000" b="1" dirty="0">
+                <a:solidFill>
+                  <a:schemeClr val="bg1"/>
+                </a:solidFill>
+              </a:rPr>
+              <a:t>A</a:t>
+            </a:r>
+          </a:p>
+        </p:txBody>
+      </p:sp>
+      <p:sp>
+        <p:nvSpPr>
+          <p:cNvPr id="29" name="node-29"/>
+          <p:cNvSpPr/>
+          <p:nvPr/>
+        </p:nvSpPr>
+        <p:spPr>
+          <a:xfrm>
+            <a:off x="6217920" y="2651760"/>
+            <a:ext cx="274320" cy="274320"/>
+          </a:xfrm>
+          <a:prstGeom prst="ellipse">
+            <a:avLst/>
+          </a:prstGeom>
+          <a:solidFill>
+            <a:schemeClr val="tx2"/>
+          </a:solidFill>
+          <a:ln>
+            <a:noFill/>
+          </a:ln>
+        </p:spPr>
+        <p:txBody>
+          <a:bodyPr wrap="none" lIns="0" tIns="0" rIns="0" bIns="0" rtlCol="0" anchor="ctr"/>
+          <a:lstStyle/>
+          <a:p>
+            <a:pPr algn="ctr" indent="0" marL="0">
+              <a:buNone/>
+            </a:pPr>
+            <a:r>
+              <a:rPr lang="en-US" sz="1000" b="1" dirty="0">
+                <a:solidFill>
+                  <a:schemeClr val="bg1"/>
+                </a:solidFill>
+              </a:rPr>
+              <a:t>B</a:t>
+            </a:r>
+          </a:p>
+        </p:txBody>
+      </p:sp>
+      <p:sp>
+        <p:nvSpPr>
+          <p:cNvPr id="30" name="node-30"/>
+          <p:cNvSpPr/>
+          <p:nvPr/>
+        </p:nvSpPr>
+        <p:spPr>
+          <a:xfrm>
+            <a:off x="6720840" y="2651760"/>
+            <a:ext cx="274320" cy="274320"/>
+          </a:xfrm>
+          <a:prstGeom prst="ellipse">
+            <a:avLst/>
+          </a:prstGeom>
+          <a:solidFill>
+            <a:schemeClr val="tx2"/>
+          </a:solidFill>
+          <a:ln>
+            <a:noFill/>
+          </a:ln>
+        </p:spPr>
+        <p:txBody>
+          <a:bodyPr wrap="none" lIns="0" tIns="0" rIns="0" bIns="0" rtlCol="0" anchor="ctr"/>
+          <a:lstStyle/>
+          <a:p>
+            <a:pPr algn="ctr" indent="0" marL="0">
+              <a:buNone/>
+            </a:pPr>
+            <a:r>
+              <a:rPr lang="en-US" sz="1000" b="1" dirty="0">
+                <a:solidFill>
+                  <a:schemeClr val="bg1"/>
+                </a:solidFill>
+              </a:rPr>
+              <a:t>C</a:t>
+            </a:r>
+          </a:p>
+        </p:txBody>
+      </p:sp>
+      <p:cxnSp>
+        <p:nvCxnSpPr>
+          <p:cNvPr id="31" name="arrow-31"/>
+          <p:cNvCxnSpPr/>
+          <p:nvPr/>
+        </p:nvCxnSpPr>
+        <p:spPr>
+          <a:xfrm>
+            <a:off x="6007608" y="2788920"/>
+            <a:ext cx="192024" cy="0"/>
+          </a:xfrm>
+          <a:prstGeom prst="straightConnector1">
+            <a:avLst/>
+          </a:prstGeom>
+          <a:ln w="19050">
+            <a:solidFill>
+              <a:schemeClr val="tx2"/>
+            </a:solidFill>
+            <a:tailEnd type="triangle" w="med" len="med"/>
+          </a:ln>
+        </p:spPr>
+      </p:cxnSp>
+      <p:cxnSp>
+        <p:nvCxnSpPr>
+          <p:cNvPr id="32" name="arrow-32"/>
+          <p:cNvCxnSpPr/>
+          <p:nvPr/>
+        </p:nvCxnSpPr>
+        <p:spPr>
+          <a:xfrm>
+            <a:off x="6510528" y="2788920"/>
+            <a:ext cx="192024" cy="0"/>
+          </a:xfrm>
+          <a:prstGeom prst="straightConnector1">
+            <a:avLst/>
+          </a:prstGeom>
+          <a:ln w="19050">
+            <a:solidFill>
+              <a:schemeClr val="tx2"/>
+            </a:solidFill>
+            <a:tailEnd type="triangle" w="med" len="med"/>
+          </a:ln>
+        </p:spPr>
+      </p:cxnSp>
+      <p:sp>
+        <p:nvSpPr>
+          <p:cNvPr id="33" name="text-33"/>
+          <p:cNvSpPr txBox="1"/>
+          <p:nvPr/>
+        </p:nvSpPr>
+        <p:spPr>
+          <a:xfrm>
+            <a:off x="7040880" y="2651760"/>
+            <a:ext cx="777240" cy="274320"/>
+          </a:xfrm>
+          <a:prstGeom prst="rect">
+            <a:avLst/>
+          </a:prstGeom>
+          <a:noFill/>
+          <a:ln/>
+        </p:spPr>
+        <p:txBody>
+          <a:bodyPr wrap="square" lIns="0" tIns="0" rIns="0" bIns="0" rtlCol="0" anchor="ctr"/>
+          <a:lstStyle/>
+          <a:p>
+            <a:pPr algn="ctr" indent="0" marL="0">
+              <a:buNone/>
+            </a:pPr>
+            <a:r>
+              <a:rPr lang="en-US" sz="1300" b="1" dirty="0">
+                <a:solidFill>
+                  <a:schemeClr val="tx2"/>
+                </a:solidFill>
+              </a:rPr>
+              <a:t>0.490</a:t>
+            </a:r>
+          </a:p>
+        </p:txBody>
+      </p:sp>
+      <p:sp>
+        <p:nvSpPr>
+          <p:cNvPr id="34" name="text-34"/>
+          <p:cNvSpPr txBox="1"/>
+          <p:nvPr/>
+        </p:nvSpPr>
+        <p:spPr>
+          <a:xfrm>
+            <a:off x="7863840" y="2651760"/>
+            <a:ext cx="777240" cy="274320"/>
+          </a:xfrm>
+          <a:prstGeom prst="rect">
+            <a:avLst/>
+          </a:prstGeom>
+          <a:noFill/>
+          <a:ln/>
+        </p:spPr>
+        <p:txBody>
+          <a:bodyPr wrap="square" lIns="0" tIns="0" rIns="0" bIns="0" rtlCol="0" anchor="ctr"/>
+          <a:lstStyle/>
+          <a:p>
+            <a:pPr algn="ctr" indent="0" marL="0">
+              <a:buNone/>
+            </a:pPr>
+            <a:r>
+              <a:rPr lang="en-US" sz="1300" b="1" dirty="0">
+                <a:solidFill>
+                  <a:schemeClr val="tx2"/>
+                </a:solidFill>
+              </a:rPr>
+              <a:t>0.000</a:t>
+            </a:r>
+          </a:p>
+        </p:txBody>
+      </p:sp>
+      <p:sp>
+        <p:nvSpPr>
+          <p:cNvPr id="35" name="row-35"/>
+          <p:cNvSpPr/>
+          <p:nvPr/>
+        </p:nvSpPr>
+        <p:spPr>
+          <a:xfrm>
+            <a:off x="4434840" y="2999232"/>
+            <a:ext cx="4251960" cy="347472"/>
+          </a:xfrm>
+          <a:prstGeom prst="roundRect">
+            <a:avLst>
+              <a:gd name="adj" fmla="val 12000"/>
+            </a:avLst>
+          </a:prstGeom>
+          <a:solidFill>
+            <a:schemeClr val="bg2"/>
+          </a:solidFill>
+          <a:ln>
+            <a:noFill/>
+          </a:ln>
+        </p:spPr>
+      </p:sp>
+      <p:sp>
+        <p:nvSpPr>
+          <p:cNvPr id="36" name="text-36"/>
+          <p:cNvSpPr txBox="1"/>
+          <p:nvPr/>
+        </p:nvSpPr>
+        <p:spPr>
+          <a:xfrm>
+            <a:off x="4544568" y="3035808"/>
+            <a:ext cx="1143000" cy="274320"/>
+          </a:xfrm>
+          <a:prstGeom prst="rect">
+            <a:avLst/>
+          </a:prstGeom>
+          <a:noFill/>
+          <a:ln/>
+        </p:spPr>
+        <p:txBody>
+          <a:bodyPr wrap="square" lIns="0" tIns="0" rIns="0" bIns="0" rtlCol="0" anchor="ctr"/>
+          <a:lstStyle/>
+          <a:p>
+            <a:pPr algn="l" indent="0" marL="0">
+              <a:buNone/>
+            </a:pPr>
+            <a:r>
+              <a:rPr lang="en-US" sz="1050" b="1" dirty="0">
+                <a:solidFill>
+                  <a:schemeClr val="accent2"/>
+                </a:solidFill>
+              </a:rPr>
+              <a:t>Our DAG (fitted)</a:t>
+            </a:r>
+          </a:p>
+        </p:txBody>
+      </p:sp>
+      <p:sp>
+        <p:nvSpPr>
+          <p:cNvPr id="37" name="node-37"/>
+          <p:cNvSpPr/>
+          <p:nvPr/>
+        </p:nvSpPr>
+        <p:spPr>
+          <a:xfrm>
+            <a:off x="5715000" y="3035808"/>
+            <a:ext cx="274320" cy="274320"/>
+          </a:xfrm>
+          <a:prstGeom prst="ellipse">
+            <a:avLst/>
+          </a:prstGeom>
+          <a:solidFill>
+            <a:schemeClr val="accent2"/>
+          </a:solidFill>
+          <a:ln>
+            <a:noFill/>
+          </a:ln>
+        </p:spPr>
+        <p:txBody>
+          <a:bodyPr wrap="none" lIns="0" tIns="0" rIns="0" bIns="0" rtlCol="0" anchor="ctr"/>
+          <a:lstStyle/>
+          <a:p>
+            <a:pPr algn="ctr" indent="0" marL="0">
+              <a:buNone/>
+            </a:pPr>
+            <a:r>
+              <a:rPr lang="en-US" sz="1000" b="1" dirty="0">
+                <a:solidFill>
+                  <a:schemeClr val="bg1"/>
+                </a:solidFill>
+              </a:rPr>
+              <a:t>A</a:t>
+            </a:r>
+          </a:p>
+        </p:txBody>
+      </p:sp>
+      <p:sp>
+        <p:nvSpPr>
+          <p:cNvPr id="38" name="node-38"/>
+          <p:cNvSpPr/>
+          <p:nvPr/>
+        </p:nvSpPr>
+        <p:spPr>
+          <a:xfrm>
+            <a:off x="6217920" y="3035808"/>
+            <a:ext cx="274320" cy="274320"/>
+          </a:xfrm>
+          <a:prstGeom prst="ellipse">
+            <a:avLst/>
+          </a:prstGeom>
+          <a:solidFill>
+            <a:schemeClr val="accent2"/>
+          </a:solidFill>
+          <a:ln>
+            <a:noFill/>
+          </a:ln>
+        </p:spPr>
+        <p:txBody>
+          <a:bodyPr wrap="none" lIns="0" tIns="0" rIns="0" bIns="0" rtlCol="0" anchor="ctr"/>
+          <a:lstStyle/>
+          <a:p>
+            <a:pPr algn="ctr" indent="0" marL="0">
+              <a:buNone/>
+            </a:pPr>
+            <a:r>
+              <a:rPr lang="en-US" sz="1000" b="1" dirty="0">
+                <a:solidFill>
+                  <a:schemeClr val="bg1"/>
+                </a:solidFill>
+              </a:rPr>
+              <a:t>B</a:t>
+            </a:r>
+          </a:p>
+        </p:txBody>
+      </p:sp>
+      <p:sp>
+        <p:nvSpPr>
+          <p:cNvPr id="39" name="node-39"/>
+          <p:cNvSpPr/>
+          <p:nvPr/>
+        </p:nvSpPr>
+        <p:spPr>
+          <a:xfrm>
+            <a:off x="6720840" y="3035808"/>
+            <a:ext cx="274320" cy="274320"/>
+          </a:xfrm>
+          <a:prstGeom prst="ellipse">
+            <a:avLst/>
+          </a:prstGeom>
+          <a:solidFill>
+            <a:schemeClr val="accent2"/>
+          </a:solidFill>
+          <a:ln>
+            <a:noFill/>
+          </a:ln>
+        </p:spPr>
+        <p:txBody>
+          <a:bodyPr wrap="none" lIns="0" tIns="0" rIns="0" bIns="0" rtlCol="0" anchor="ctr"/>
+          <a:lstStyle/>
+          <a:p>
+            <a:pPr algn="ctr" indent="0" marL="0">
+              <a:buNone/>
+            </a:pPr>
+            <a:r>
+              <a:rPr lang="en-US" sz="1000" b="1" dirty="0">
+                <a:solidFill>
+                  <a:schemeClr val="bg1"/>
+                </a:solidFill>
+              </a:rPr>
+              <a:t>C</a:t>
+            </a:r>
+          </a:p>
+        </p:txBody>
+      </p:sp>
+      <p:cxnSp>
+        <p:nvCxnSpPr>
+          <p:cNvPr id="40" name="arrow-40"/>
+          <p:cNvCxnSpPr/>
+          <p:nvPr/>
+        </p:nvCxnSpPr>
+        <p:spPr>
+          <a:xfrm>
+            <a:off x="6007608" y="3172968"/>
+            <a:ext cx="192024" cy="0"/>
+          </a:xfrm>
+          <a:prstGeom prst="straightConnector1">
+            <a:avLst/>
+          </a:prstGeom>
+          <a:ln w="19050">
+            <a:solidFill>
+              <a:schemeClr val="accent2"/>
+            </a:solidFill>
+            <a:tailEnd type="triangle" w="med" len="med"/>
+          </a:ln>
+        </p:spPr>
+      </p:cxnSp>
+      <p:cxnSp>
+        <p:nvCxnSpPr>
+          <p:cNvPr id="41" name="arrow-41"/>
+          <p:cNvCxnSpPr/>
+          <p:nvPr/>
+        </p:nvCxnSpPr>
+        <p:spPr>
+          <a:xfrm>
+            <a:off x="6510528" y="3172968"/>
+            <a:ext cx="192024" cy="0"/>
+          </a:xfrm>
+          <a:prstGeom prst="straightConnector1">
+            <a:avLst/>
+          </a:prstGeom>
+          <a:ln w="19050">
+            <a:solidFill>
+              <a:schemeClr val="accent2"/>
+            </a:solidFill>
+            <a:tailEnd type="triangle" w="med" len="med"/>
+          </a:ln>
+        </p:spPr>
+      </p:cxnSp>
+      <p:sp>
+        <p:nvSpPr>
+          <p:cNvPr id="42" name="text-42"/>
+          <p:cNvSpPr txBox="1"/>
+          <p:nvPr/>
+        </p:nvSpPr>
+        <p:spPr>
+          <a:xfrm>
+            <a:off x="7040880" y="3035808"/>
+            <a:ext cx="777240" cy="274320"/>
+          </a:xfrm>
+          <a:prstGeom prst="rect">
+            <a:avLst/>
+          </a:prstGeom>
+          <a:noFill/>
+          <a:ln/>
+        </p:spPr>
+        <p:txBody>
+          <a:bodyPr wrap="square" lIns="0" tIns="0" rIns="0" bIns="0" rtlCol="0" anchor="ctr"/>
+          <a:lstStyle/>
+          <a:p>
+            <a:pPr algn="ctr" indent="0" marL="0">
+              <a:buNone/>
+            </a:pPr>
+            <a:r>
+              <a:rPr lang="en-US" sz="1300" b="1" dirty="0">
+                <a:solidFill>
+                  <a:schemeClr val="accent2"/>
+                </a:solidFill>
+              </a:rPr>
+              <a:t>0.498</a:t>
+            </a:r>
+          </a:p>
+        </p:txBody>
+      </p:sp>
+      <p:sp>
+        <p:nvSpPr>
+          <p:cNvPr id="43" name="text-43"/>
+          <p:cNvSpPr txBox="1"/>
+          <p:nvPr/>
+        </p:nvSpPr>
+        <p:spPr>
+          <a:xfrm>
+            <a:off x="7863840" y="3035808"/>
+            <a:ext cx="777240" cy="274320"/>
+          </a:xfrm>
+          <a:prstGeom prst="rect">
+            <a:avLst/>
+          </a:prstGeom>
+          <a:noFill/>
+          <a:ln/>
+        </p:spPr>
+        <p:txBody>
+          <a:bodyPr wrap="square" lIns="0" tIns="0" rIns="0" bIns="0" rtlCol="0" anchor="ctr"/>
+          <a:lstStyle/>
+          <a:p>
+            <a:pPr algn="ctr" indent="0" marL="0">
+              <a:buNone/>
+            </a:pPr>
+            <a:r>
+              <a:rPr lang="en-US" sz="1300" b="1" dirty="0">
+                <a:solidFill>
+                  <a:schemeClr val="accent2"/>
+                </a:solidFill>
+              </a:rPr>
+              <a:t>0.000</a:t>
+            </a:r>
+          </a:p>
+        </p:txBody>
+      </p:sp>
+      <p:sp>
+        <p:nvSpPr>
+          <p:cNvPr id="44" name="row-44"/>
+          <p:cNvSpPr/>
+          <p:nvPr/>
+        </p:nvSpPr>
+        <p:spPr>
+          <a:xfrm>
+            <a:off x="4434840" y="3383280"/>
+            <a:ext cx="4251960" cy="347472"/>
+          </a:xfrm>
+          <a:prstGeom prst="roundRect">
+            <a:avLst>
+              <a:gd name="adj" fmla="val 12000"/>
+            </a:avLst>
+          </a:prstGeom>
+          <a:solidFill>
+            <a:schemeClr val="bg2"/>
+          </a:solidFill>
+          <a:ln>
+            <a:noFill/>
+          </a:ln>
+        </p:spPr>
+      </p:sp>
+      <p:sp>
+        <p:nvSpPr>
+          <p:cNvPr id="45" name="text-45"/>
+          <p:cNvSpPr txBox="1"/>
+          <p:nvPr/>
+        </p:nvSpPr>
+        <p:spPr>
+          <a:xfrm>
+            <a:off x="4544568" y="3419856"/>
+            <a:ext cx="1143000" cy="274320"/>
+          </a:xfrm>
+          <a:prstGeom prst="rect">
+            <a:avLst/>
+          </a:prstGeom>
+          <a:noFill/>
+          <a:ln/>
+        </p:spPr>
+        <p:txBody>
+          <a:bodyPr wrap="square" lIns="0" tIns="0" rIns="0" bIns="0" rtlCol="0" anchor="ctr"/>
+          <a:lstStyle/>
+          <a:p>
+            <a:pPr algn="l" indent="0" marL="0">
+              <a:buNone/>
+            </a:pPr>
+            <a:r>
+              <a:rPr lang="en-US" sz="1050" b="1" dirty="0">
+                <a:solidFill>
+                  <a:schemeClr val="accent4"/>
+                </a:solidFill>
+              </a:rPr>
+              <a:t>Reversed DAG</a:t>
+            </a:r>
+          </a:p>
+        </p:txBody>
+      </p:sp>
+      <p:sp>
+        <p:nvSpPr>
+          <p:cNvPr id="46" name="node-46"/>
+          <p:cNvSpPr/>
+          <p:nvPr/>
+        </p:nvSpPr>
+        <p:spPr>
+          <a:xfrm>
+            <a:off x="5715000" y="3419856"/>
+            <a:ext cx="274320" cy="274320"/>
+          </a:xfrm>
+          <a:prstGeom prst="ellipse">
+            <a:avLst/>
+          </a:prstGeom>
+          <a:solidFill>
+            <a:schemeClr val="accent4"/>
+          </a:solidFill>
+          <a:ln>
+            <a:noFill/>
+          </a:ln>
+        </p:spPr>
+        <p:txBody>
+          <a:bodyPr wrap="none" lIns="0" tIns="0" rIns="0" bIns="0" rtlCol="0" anchor="ctr"/>
+          <a:lstStyle/>
+          <a:p>
+            <a:pPr algn="ctr" indent="0" marL="0">
+              <a:buNone/>
+            </a:pPr>
+            <a:r>
+              <a:rPr lang="en-US" sz="1000" b="1" dirty="0">
+                <a:solidFill>
+                  <a:schemeClr val="bg1"/>
+                </a:solidFill>
+              </a:rPr>
+              <a:t>A</a:t>
+            </a:r>
+          </a:p>
+        </p:txBody>
+      </p:sp>
+      <p:sp>
+        <p:nvSpPr>
+          <p:cNvPr id="47" name="node-47"/>
+          <p:cNvSpPr/>
+          <p:nvPr/>
+        </p:nvSpPr>
+        <p:spPr>
+          <a:xfrm>
+            <a:off x="6217920" y="3419856"/>
+            <a:ext cx="274320" cy="274320"/>
+          </a:xfrm>
+          <a:prstGeom prst="ellipse">
+            <a:avLst/>
+          </a:prstGeom>
+          <a:solidFill>
+            <a:schemeClr val="accent4"/>
+          </a:solidFill>
+          <a:ln>
+            <a:noFill/>
+          </a:ln>
+        </p:spPr>
+        <p:txBody>
+          <a:bodyPr wrap="none" lIns="0" tIns="0" rIns="0" bIns="0" rtlCol="0" anchor="ctr"/>
+          <a:lstStyle/>
+          <a:p>
+            <a:pPr algn="ctr" indent="0" marL="0">
+              <a:buNone/>
+            </a:pPr>
+            <a:r>
+              <a:rPr lang="en-US" sz="1000" b="1" dirty="0">
+                <a:solidFill>
+                  <a:schemeClr val="bg1"/>
+                </a:solidFill>
+              </a:rPr>
+              <a:t>B</a:t>
+            </a:r>
+          </a:p>
+        </p:txBody>
+      </p:sp>
+      <p:sp>
+        <p:nvSpPr>
+          <p:cNvPr id="48" name="node-48"/>
+          <p:cNvSpPr/>
+          <p:nvPr/>
+        </p:nvSpPr>
+        <p:spPr>
+          <a:xfrm>
+            <a:off x="6720840" y="3419856"/>
+            <a:ext cx="274320" cy="274320"/>
+          </a:xfrm>
+          <a:prstGeom prst="ellipse">
+            <a:avLst/>
+          </a:prstGeom>
+          <a:solidFill>
+            <a:schemeClr val="accent4"/>
+          </a:solidFill>
+          <a:ln>
+            <a:noFill/>
+          </a:ln>
+        </p:spPr>
+        <p:txBody>
+          <a:bodyPr wrap="none" lIns="0" tIns="0" rIns="0" bIns="0" rtlCol="0" anchor="ctr"/>
+          <a:lstStyle/>
+          <a:p>
+            <a:pPr algn="ctr" indent="0" marL="0">
+              <a:buNone/>
+            </a:pPr>
+            <a:r>
+              <a:rPr lang="en-US" sz="1000" b="1" dirty="0">
+                <a:solidFill>
+                  <a:schemeClr val="bg1"/>
+                </a:solidFill>
+              </a:rPr>
+              <a:t>C</a:t>
+            </a:r>
+          </a:p>
+        </p:txBody>
+      </p:sp>
+      <p:cxnSp>
+        <p:nvCxnSpPr>
+          <p:cNvPr id="49" name="arrow-49"/>
+          <p:cNvCxnSpPr/>
+          <p:nvPr/>
+        </p:nvCxnSpPr>
+        <p:spPr>
+          <a:xfrm flipH="1">
+            <a:off x="6007608" y="3557016"/>
+            <a:ext cx="192024" cy="0"/>
+          </a:xfrm>
+          <a:prstGeom prst="straightConnector1">
+            <a:avLst/>
+          </a:prstGeom>
+          <a:ln w="19050">
+            <a:solidFill>
+              <a:schemeClr val="accent4"/>
+            </a:solidFill>
+            <a:tailEnd type="triangle" w="med" len="med"/>
+          </a:ln>
+        </p:spPr>
+      </p:cxnSp>
+      <p:cxnSp>
+        <p:nvCxnSpPr>
+          <p:cNvPr id="50" name="arrow-50"/>
+          <p:cNvCxnSpPr/>
+          <p:nvPr/>
+        </p:nvCxnSpPr>
+        <p:spPr>
+          <a:xfrm flipH="1">
+            <a:off x="6510528" y="3557016"/>
+            <a:ext cx="192024" cy="0"/>
+          </a:xfrm>
+          <a:prstGeom prst="straightConnector1">
+            <a:avLst/>
+          </a:prstGeom>
+          <a:ln w="19050">
+            <a:solidFill>
+              <a:schemeClr val="accent4"/>
+            </a:solidFill>
+            <a:tailEnd type="triangle" w="med" len="med"/>
+          </a:ln>
+        </p:spPr>
+      </p:cxnSp>
+      <p:sp>
+        <p:nvSpPr>
+          <p:cNvPr id="51" name="text-51"/>
+          <p:cNvSpPr txBox="1"/>
+          <p:nvPr/>
+        </p:nvSpPr>
+        <p:spPr>
+          <a:xfrm>
+            <a:off x="7040880" y="3419856"/>
+            <a:ext cx="777240" cy="274320"/>
+          </a:xfrm>
+          <a:prstGeom prst="rect">
+            <a:avLst/>
+          </a:prstGeom>
+          <a:noFill/>
+          <a:ln/>
+        </p:spPr>
+        <p:txBody>
+          <a:bodyPr wrap="square" lIns="0" tIns="0" rIns="0" bIns="0" rtlCol="0" anchor="ctr"/>
+          <a:lstStyle/>
+          <a:p>
+            <a:pPr algn="ctr" indent="0" marL="0">
+              <a:buNone/>
+            </a:pPr>
+            <a:r>
+              <a:rPr lang="en-US" sz="1300" b="1" dirty="0">
+                <a:solidFill>
+                  <a:schemeClr val="accent4"/>
+                </a:solidFill>
+              </a:rPr>
+              <a:t>0.000</a:t>
+            </a:r>
+          </a:p>
+        </p:txBody>
+      </p:sp>
+      <p:sp>
+        <p:nvSpPr>
+          <p:cNvPr id="52" name="text-52"/>
+          <p:cNvSpPr txBox="1"/>
+          <p:nvPr/>
+        </p:nvSpPr>
+        <p:spPr>
+          <a:xfrm>
+            <a:off x="7863840" y="3419856"/>
+            <a:ext cx="777240" cy="274320"/>
+          </a:xfrm>
+          <a:prstGeom prst="rect">
+            <a:avLst/>
+          </a:prstGeom>
+          <a:noFill/>
+          <a:ln/>
+        </p:spPr>
+        <p:txBody>
+          <a:bodyPr wrap="square" lIns="0" tIns="0" rIns="0" bIns="0" rtlCol="0" anchor="ctr"/>
+          <a:lstStyle/>
+          <a:p>
+            <a:pPr algn="ctr" indent="0" marL="0">
+              <a:buNone/>
+            </a:pPr>
+            <a:r>
+              <a:rPr lang="en-US" sz="1300" b="1" dirty="0">
+                <a:solidFill>
+                  <a:schemeClr val="accent4"/>
+                </a:solidFill>
+              </a:rPr>
+              <a:t>0.514</a:t>
+            </a:r>
+          </a:p>
+        </p:txBody>
+      </p:sp>
+      <p:sp>
+        <p:nvSpPr>
+          <p:cNvPr id="53" name="chain-note-53"/>
+          <p:cNvSpPr txBox="1"/>
+          <p:nvPr/>
+        </p:nvSpPr>
+        <p:spPr>
+          <a:xfrm>
+            <a:off x="4434840" y="3822192"/>
+            <a:ext cx="4251960" cy="365760"/>
+          </a:xfrm>
+          <a:prstGeom prst="rect">
+            <a:avLst/>
+          </a:prstGeom>
+          <a:noFill/>
+          <a:ln/>
+        </p:spPr>
+        <p:txBody>
+          <a:bodyPr wrap="square" lIns="0" tIns="0" rIns="0" bIns="0" rtlCol="0" anchor="t"/>
+          <a:lstStyle/>
+          <a:p>
+            <a:pPr algn="l" indent="0" marL="0">
+              <a:buNone/>
+            </a:pPr>
+            <a:r>
+              <a:rPr lang="en-US" sz="950" i="1" dirty="0">
+                <a:solidFill>
+                  <a:schemeClr val="accent5"/>
+                </a:solidFill>
+              </a:rPr>
+              <a:t>Forcing A changes C, forcing C does not change A. The reversed graph fits the same data but gets both answers wrong.</a:t>
+            </a:r>
+          </a:p>
+        </p:txBody>
+      </p:sp>
+      <p:sp>
+        <p:nvSpPr>
+          <p:cNvPr id="54" name="result-54"/>
+          <p:cNvSpPr txBox="1"/>
+          <p:nvPr/>
+        </p:nvSpPr>
+        <p:spPr>
+          <a:xfrm>
+            <a:off x="457200" y="4261104"/>
+            <a:ext cx="8229600" cy="365760"/>
+          </a:xfrm>
+          <a:prstGeom prst="rect">
+            <a:avLst/>
+          </a:prstGeom>
+          <a:noFill/>
+          <a:ln/>
+        </p:spPr>
+        <p:txBody>
+          <a:bodyPr wrap="square" lIns="0" tIns="0" rIns="0" bIns="0" rtlCol="0" anchor="t"/>
+          <a:lstStyle/>
+          <a:p>
+            <a:pPr algn="l" indent="0" marL="0">
+              <a:buNone/>
+            </a:pPr>
+            <a:r>
+              <a:rPr lang="en-US" sz="1100" dirty="0">
+                <a:solidFill>
+                  <a:schemeClr val="tx1"/>
+                </a:solidFill>
+              </a:rPr>
+              <a:t>On 5 fully known test graphs (96 queries, 32 with a real effect):  </a:t>
+            </a:r>
+            <a:r>
+              <a:rPr lang="en-US" sz="1100" b="1" dirty="0">
+                <a:solidFill>
+                  <a:schemeClr val="accent2"/>
+                </a:solidFill>
+              </a:rPr>
+              <a:t>our DAG 28 / 32</a:t>
+            </a:r>
+            <a:r>
+              <a:rPr lang="en-US" sz="1100" dirty="0">
+                <a:solidFill>
+                  <a:schemeClr val="tx1"/>
+                </a:solidFill>
+              </a:rPr>
+              <a:t>  ·  reversed 0 / 32  ·  empty graph 0 / 32</a:t>
+            </a:r>
+          </a:p>
+          <a:p>
+            <a:pPr algn="l" indent="0" marL="0">
+              <a:buNone/>
+            </a:pPr>
+            <a:r>
+              <a:rPr lang="en-US" sz="950" dirty="0">
+                <a:solidFill>
+                  <a:schemeClr val="accent5"/>
+                </a:solidFill>
+              </a:rPr>
+              <a:t>A query counts only if the graph gets “is there an effect?” right and the size within 0.05. All 96 queries: 92 vs 36 vs 64.</a:t>
+            </a:r>
           </a:p>
         </p:txBody>
       </p:sp>
@@ -9700,584 +10711,6 @@
             <a:fld id="{F7021451-1387-4CA6-816F-3879F97B5CBC}" type="slidenum">
               <a:rPr b="0" lang="en-US"/>
               <a:t>3</a:t>
-            </a:fld>
-            <a:endParaRPr lang="en-US"/>
-          </a:p>
-        </p:txBody>
-      </p:sp>
-    </p:spTree>
-  </p:cSld>
-  <p:clrMapOvr>
-    <a:masterClrMapping/>
-  </p:clrMapOvr>
-</p:sld>
-</file>
-
-<file path=ppt/slides/slide4.xml><?xml version="1.0" encoding="utf-8"?>
-<p:sld xmlns:a="http://schemas.openxmlformats.org/drawingml/2006/main" xmlns:r="http://schemas.openxmlformats.org/officeDocument/2006/relationships" xmlns:p="http://schemas.openxmlformats.org/presentationml/2006/main">
-  <p:cSld name="Slide 4">
-    <p:spTree>
-      <p:nvGrpSpPr>
-        <p:cNvPr id="1" name=""/>
-        <p:cNvGrpSpPr/>
-        <p:nvPr/>
-      </p:nvGrpSpPr>
-      <p:grpSpPr>
-        <a:xfrm>
-          <a:off x="0" y="0"/>
-          <a:ext cx="0" cy="0"/>
-          <a:chOff x="0" y="0"/>
-          <a:chExt cx="0" cy="0"/>
-        </a:xfrm>
-      </p:grpSpPr>
-      <p:sp>
-        <p:nvSpPr>
-          <p:cNvPr id="2" name="Text 1"/>
-          <p:cNvSpPr/>
-          <p:nvPr>
-            <p:ph idx="101" type="body" hasCustomPrompt="1"/>
-          </p:nvPr>
-        </p:nvSpPr>
-        <p:spPr>
-          <a:xfrm>
-            <a:off x="658368" y="128016"/>
-            <a:ext cx="7315200" cy="274320"/>
-          </a:xfrm>
-          <a:prstGeom prst="rect">
-            <a:avLst/>
-          </a:prstGeom>
-          <a:noFill/>
-          <a:ln/>
-        </p:spPr>
-        <p:txBody>
-          <a:bodyPr wrap="square" lIns="0" tIns="0" rIns="0" bIns="0" rtlCol="0" anchor="ctr"/>
-          <a:lstStyle/>
-          <a:p>
-            <a:pPr indent="0" marL="0">
-              <a:buNone/>
-            </a:pPr>
-            <a:r>
-              <a:rPr lang="en-US" sz="1100" b="1" dirty="0">
-                <a:solidFill>
-                  <a:schemeClr val="accent1"/>
-                </a:solidFill>
-              </a:rPr>
-              <a:t>HEADLINE RESULTS</a:t>
-            </a:r>
-            <a:endParaRPr lang="en-US" sz="1100" dirty="0"/>
-          </a:p>
-        </p:txBody>
-      </p:sp>
-      <p:sp>
-        <p:nvSpPr>
-          <p:cNvPr id="3" name="Text 1"/>
-          <p:cNvSpPr/>
-          <p:nvPr>
-            <p:ph idx="102" type="title" hasCustomPrompt="1"/>
-          </p:nvPr>
-        </p:nvSpPr>
-        <p:spPr>
-          <a:xfrm>
-            <a:off x="457200" y="411480"/>
-            <a:ext cx="8229600" cy="548640"/>
-          </a:xfrm>
-          <a:prstGeom prst="rect">
-            <a:avLst/>
-          </a:prstGeom>
-          <a:noFill/>
-          <a:ln/>
-        </p:spPr>
-        <p:txBody>
-          <a:bodyPr wrap="square" lIns="0" tIns="0" rIns="0" bIns="0" rtlCol="0" anchor="t"/>
-          <a:lstStyle/>
-          <a:p>
-            <a:pPr algn="l" indent="0" marL="0">
-              <a:buNone/>
-            </a:pPr>
-            <a:r>
-              <a:rPr lang="en-US" sz="2600" b="1" dirty="0">
-                <a:solidFill>
-                  <a:schemeClr val="tx2"/>
-                </a:solidFill>
-              </a:rPr>
-              <a:t>Four numbers to remember</a:t>
-            </a:r>
-            <a:endParaRPr lang="en-US" sz="2600" dirty="0"/>
-          </a:p>
-        </p:txBody>
-      </p:sp>
-      <p:sp>
-        <p:nvSpPr>
-          <p:cNvPr id="4" name="card-40"/>
-          <p:cNvSpPr/>
-          <p:nvPr/>
-        </p:nvSpPr>
-        <p:spPr>
-          <a:xfrm>
-            <a:off x="457200" y="1280160"/>
-            <a:ext cx="1828800" cy="2331720"/>
-          </a:xfrm>
-          <a:prstGeom prst="roundRect">
-            <a:avLst>
-              <a:gd name="adj" fmla="val 4000"/>
-            </a:avLst>
-          </a:prstGeom>
-          <a:solidFill>
-            <a:schemeClr val="bg2"/>
-          </a:solidFill>
-          <a:ln w="12700">
-            <a:solidFill>
-              <a:schemeClr val="bg2"/>
-            </a:solidFill>
-            <a:prstDash val="solid"/>
-          </a:ln>
-        </p:spPr>
-      </p:sp>
-      <p:sp>
-        <p:nvSpPr>
-          <p:cNvPr id="5" name="text-41"/>
-          <p:cNvSpPr txBox="1"/>
-          <p:nvPr/>
-        </p:nvSpPr>
-        <p:spPr>
-          <a:xfrm>
-            <a:off x="594360" y="1463040"/>
-            <a:ext cx="1554480" cy="822960"/>
-          </a:xfrm>
-          <a:prstGeom prst="rect">
-            <a:avLst/>
-          </a:prstGeom>
-          <a:noFill/>
-          <a:ln/>
-        </p:spPr>
-        <p:txBody>
-          <a:bodyPr wrap="square" lIns="0" tIns="0" rIns="0" bIns="0" rtlCol="0" anchor="ctr"/>
-          <a:lstStyle/>
-          <a:p>
-            <a:pPr algn="ctr" indent="0" marL="0">
-              <a:buNone/>
-            </a:pPr>
-            <a:r>
-              <a:rPr lang="en-US" sz="3400" b="1" dirty="0">
-                <a:solidFill>
-                  <a:schemeClr val="accent1"/>
-                </a:solidFill>
-              </a:rPr>
-              <a:t>98.5%</a:t>
-            </a:r>
-            <a:endParaRPr lang="en-US" sz="3400" dirty="0"/>
-          </a:p>
-        </p:txBody>
-      </p:sp>
-      <p:sp>
-        <p:nvSpPr>
-          <p:cNvPr id="6" name="text-42"/>
-          <p:cNvSpPr txBox="1"/>
-          <p:nvPr/>
-        </p:nvSpPr>
-        <p:spPr>
-          <a:xfrm>
-            <a:off x="594360" y="2377440"/>
-            <a:ext cx="1554480" cy="1097280"/>
-          </a:xfrm>
-          <a:prstGeom prst="rect">
-            <a:avLst/>
-          </a:prstGeom>
-          <a:noFill/>
-          <a:ln/>
-        </p:spPr>
-        <p:txBody>
-          <a:bodyPr wrap="square" lIns="0" tIns="0" rIns="0" bIns="0" rtlCol="0" anchor="t"/>
-          <a:lstStyle/>
-          <a:p>
-            <a:pPr algn="ctr" indent="0" marL="0">
-              <a:buNone/>
-            </a:pPr>
-            <a:r>
-              <a:rPr lang="en-US" sz="1300" dirty="0">
-                <a:solidFill>
-                  <a:schemeClr val="tx1"/>
-                </a:solidFill>
-              </a:rPr>
-              <a:t>of test labels reproduced by parser + PC, with no learning</a:t>
-            </a:r>
-            <a:endParaRPr lang="en-US" sz="1300" dirty="0"/>
-          </a:p>
-        </p:txBody>
-      </p:sp>
-      <p:sp>
-        <p:nvSpPr>
-          <p:cNvPr id="7" name="card-43"/>
-          <p:cNvSpPr/>
-          <p:nvPr/>
-        </p:nvSpPr>
-        <p:spPr>
-          <a:xfrm>
-            <a:off x="2560320" y="1280160"/>
-            <a:ext cx="1828800" cy="2331720"/>
-          </a:xfrm>
-          <a:prstGeom prst="roundRect">
-            <a:avLst>
-              <a:gd name="adj" fmla="val 4000"/>
-            </a:avLst>
-          </a:prstGeom>
-          <a:solidFill>
-            <a:schemeClr val="bg2"/>
-          </a:solidFill>
-          <a:ln w="12700">
-            <a:solidFill>
-              <a:schemeClr val="bg2"/>
-            </a:solidFill>
-            <a:prstDash val="solid"/>
-          </a:ln>
-        </p:spPr>
-      </p:sp>
-      <p:sp>
-        <p:nvSpPr>
-          <p:cNvPr id="8" name="text-44"/>
-          <p:cNvSpPr txBox="1"/>
-          <p:nvPr/>
-        </p:nvSpPr>
-        <p:spPr>
-          <a:xfrm>
-            <a:off x="2697480" y="1463040"/>
-            <a:ext cx="1554480" cy="822960"/>
-          </a:xfrm>
-          <a:prstGeom prst="rect">
-            <a:avLst/>
-          </a:prstGeom>
-          <a:noFill/>
-          <a:ln/>
-        </p:spPr>
-        <p:txBody>
-          <a:bodyPr wrap="square" lIns="0" tIns="0" rIns="0" bIns="0" rtlCol="0" anchor="ctr"/>
-          <a:lstStyle/>
-          <a:p>
-            <a:pPr algn="ctr" indent="0" marL="0">
-              <a:buNone/>
-            </a:pPr>
-            <a:r>
-              <a:rPr lang="en-US" sz="3400" b="1" dirty="0">
-                <a:solidFill>
-                  <a:schemeClr val="accent2"/>
-                </a:solidFill>
-              </a:rPr>
-              <a:t>0.957</a:t>
-            </a:r>
-            <a:endParaRPr lang="en-US" sz="3400" dirty="0"/>
-          </a:p>
-        </p:txBody>
-      </p:sp>
-      <p:sp>
-        <p:nvSpPr>
-          <p:cNvPr id="9" name="text-45"/>
-          <p:cNvSpPr txBox="1"/>
-          <p:nvPr/>
-        </p:nvSpPr>
-        <p:spPr>
-          <a:xfrm>
-            <a:off x="2697480" y="2377440"/>
-            <a:ext cx="1554480" cy="1097280"/>
-          </a:xfrm>
-          <a:prstGeom prst="rect">
-            <a:avLst/>
-          </a:prstGeom>
-          <a:noFill/>
-          <a:ln/>
-        </p:spPr>
-        <p:txBody>
-          <a:bodyPr wrap="square" lIns="0" tIns="0" rIns="0" bIns="0" rtlCol="0" anchor="t"/>
-          <a:lstStyle/>
-          <a:p>
-            <a:pPr algn="ctr" indent="0" marL="0">
-              <a:buNone/>
-            </a:pPr>
-            <a:r>
-              <a:rPr lang="en-US" sz="1300" dirty="0">
-                <a:solidFill>
-                  <a:schemeClr val="tx1"/>
-                </a:solidFill>
-              </a:rPr>
-              <a:t>test F1 of the Random Forest (95% CI 0.921 to 0.982)</a:t>
-            </a:r>
-            <a:endParaRPr lang="en-US" sz="1300" dirty="0"/>
-          </a:p>
-        </p:txBody>
-      </p:sp>
-      <p:sp>
-        <p:nvSpPr>
-          <p:cNvPr id="10" name="card-46"/>
-          <p:cNvSpPr/>
-          <p:nvPr/>
-        </p:nvSpPr>
-        <p:spPr>
-          <a:xfrm>
-            <a:off x="4663440" y="1280160"/>
-            <a:ext cx="1828800" cy="2331720"/>
-          </a:xfrm>
-          <a:prstGeom prst="roundRect">
-            <a:avLst>
-              <a:gd name="adj" fmla="val 4000"/>
-            </a:avLst>
-          </a:prstGeom>
-          <a:solidFill>
-            <a:schemeClr val="bg2"/>
-          </a:solidFill>
-          <a:ln w="12700">
-            <a:solidFill>
-              <a:schemeClr val="bg2"/>
-            </a:solidFill>
-            <a:prstDash val="solid"/>
-          </a:ln>
-        </p:spPr>
-      </p:sp>
-      <p:sp>
-        <p:nvSpPr>
-          <p:cNvPr id="11" name="text-47"/>
-          <p:cNvSpPr txBox="1"/>
-          <p:nvPr/>
-        </p:nvSpPr>
-        <p:spPr>
-          <a:xfrm>
-            <a:off x="4800600" y="1463040"/>
-            <a:ext cx="1554480" cy="822960"/>
-          </a:xfrm>
-          <a:prstGeom prst="rect">
-            <a:avLst/>
-          </a:prstGeom>
-          <a:noFill/>
-          <a:ln/>
-        </p:spPr>
-        <p:txBody>
-          <a:bodyPr wrap="square" lIns="0" tIns="0" rIns="0" bIns="0" rtlCol="0" anchor="ctr"/>
-          <a:lstStyle/>
-          <a:p>
-            <a:pPr algn="ctr" indent="0" marL="0">
-              <a:buNone/>
-            </a:pPr>
-            <a:r>
-              <a:rPr lang="en-US" sz="3400" b="1" dirty="0">
-                <a:solidFill>
-                  <a:schemeClr val="accent1"/>
-                </a:solidFill>
-              </a:rPr>
-              <a:t>0.89</a:t>
-            </a:r>
-            <a:endParaRPr lang="en-US" sz="3400" dirty="0"/>
-          </a:p>
-        </p:txBody>
-      </p:sp>
-      <p:sp>
-        <p:nvSpPr>
-          <p:cNvPr id="12" name="text-48"/>
-          <p:cNvSpPr txBox="1"/>
-          <p:nvPr/>
-        </p:nvSpPr>
-        <p:spPr>
-          <a:xfrm>
-            <a:off x="4800600" y="2377440"/>
-            <a:ext cx="1554480" cy="1097280"/>
-          </a:xfrm>
-          <a:prstGeom prst="rect">
-            <a:avLst/>
-          </a:prstGeom>
-          <a:noFill/>
-          <a:ln/>
-        </p:spPr>
-        <p:txBody>
-          <a:bodyPr wrap="square" lIns="0" tIns="0" rIns="0" bIns="0" rtlCol="0" anchor="t"/>
-          <a:lstStyle/>
-          <a:p>
-            <a:pPr algn="ctr" indent="0" marL="0">
-              <a:buNone/>
-            </a:pPr>
-            <a:r>
-              <a:rPr lang="en-US" sz="1300" dirty="0">
-                <a:solidFill>
-                  <a:schemeClr val="tx1"/>
-                </a:solidFill>
-              </a:rPr>
-              <a:t>edge precision of the predicted DAGs, with recall 1.00</a:t>
-            </a:r>
-            <a:endParaRPr lang="en-US" sz="1300" dirty="0"/>
-          </a:p>
-        </p:txBody>
-      </p:sp>
-      <p:sp>
-        <p:nvSpPr>
-          <p:cNvPr id="13" name="card-49"/>
-          <p:cNvSpPr/>
-          <p:nvPr/>
-        </p:nvSpPr>
-        <p:spPr>
-          <a:xfrm>
-            <a:off x="6766560" y="1280160"/>
-            <a:ext cx="1828800" cy="2331720"/>
-          </a:xfrm>
-          <a:prstGeom prst="roundRect">
-            <a:avLst>
-              <a:gd name="adj" fmla="val 4000"/>
-            </a:avLst>
-          </a:prstGeom>
-          <a:solidFill>
-            <a:schemeClr val="bg2"/>
-          </a:solidFill>
-          <a:ln w="12700">
-            <a:solidFill>
-              <a:schemeClr val="bg2"/>
-            </a:solidFill>
-            <a:prstDash val="solid"/>
-          </a:ln>
-        </p:spPr>
-      </p:sp>
-      <p:sp>
-        <p:nvSpPr>
-          <p:cNvPr id="14" name="text-50"/>
-          <p:cNvSpPr txBox="1"/>
-          <p:nvPr/>
-        </p:nvSpPr>
-        <p:spPr>
-          <a:xfrm>
-            <a:off x="6903720" y="1463040"/>
-            <a:ext cx="1554480" cy="822960"/>
-          </a:xfrm>
-          <a:prstGeom prst="rect">
-            <a:avLst/>
-          </a:prstGeom>
-          <a:noFill/>
-          <a:ln/>
-        </p:spPr>
-        <p:txBody>
-          <a:bodyPr wrap="square" lIns="0" tIns="0" rIns="0" bIns="0" rtlCol="0" anchor="ctr"/>
-          <a:lstStyle/>
-          <a:p>
-            <a:pPr algn="ctr" indent="0" marL="0">
-              <a:buNone/>
-            </a:pPr>
-            <a:r>
-              <a:rPr lang="en-US" sz="3400" b="1" dirty="0">
-                <a:solidFill>
-                  <a:schemeClr val="accent2"/>
-                </a:solidFill>
-              </a:rPr>
-              <a:t>28 / 32</a:t>
-            </a:r>
-            <a:endParaRPr lang="en-US" sz="3400" dirty="0"/>
-          </a:p>
-        </p:txBody>
-      </p:sp>
-      <p:sp>
-        <p:nvSpPr>
-          <p:cNvPr id="15" name="text-51"/>
-          <p:cNvSpPr txBox="1"/>
-          <p:nvPr/>
-        </p:nvSpPr>
-        <p:spPr>
-          <a:xfrm>
-            <a:off x="6903720" y="2377440"/>
-            <a:ext cx="1554480" cy="1097280"/>
-          </a:xfrm>
-          <a:prstGeom prst="rect">
-            <a:avLst/>
-          </a:prstGeom>
-          <a:noFill/>
-          <a:ln/>
-        </p:spPr>
-        <p:txBody>
-          <a:bodyPr wrap="square" lIns="0" tIns="0" rIns="0" bIns="0" rtlCol="0" anchor="t"/>
-          <a:lstStyle/>
-          <a:p>
-            <a:pPr algn="ctr" indent="0" marL="0">
-              <a:buNone/>
-            </a:pPr>
-            <a:r>
-              <a:rPr lang="en-US" sz="1300" dirty="0">
-                <a:solidFill>
-                  <a:schemeClr val="tx1"/>
-                </a:solidFill>
-              </a:rPr>
-              <a:t>real what-if effects answered correctly; baselines get 0</a:t>
-            </a:r>
-            <a:endParaRPr lang="en-US" sz="1300" dirty="0"/>
-          </a:p>
-        </p:txBody>
-      </p:sp>
-      <p:sp>
-        <p:nvSpPr>
-          <p:cNvPr id="16" name="text-52"/>
-          <p:cNvSpPr txBox="1"/>
-          <p:nvPr/>
-        </p:nvSpPr>
-        <p:spPr>
-          <a:xfrm>
-            <a:off x="457200" y="3931920"/>
-            <a:ext cx="8229600" cy="365760"/>
-          </a:xfrm>
-          <a:prstGeom prst="rect">
-            <a:avLst/>
-          </a:prstGeom>
-          <a:noFill/>
-          <a:ln/>
-        </p:spPr>
-        <p:txBody>
-          <a:bodyPr wrap="square" lIns="0" tIns="0" rIns="0" bIns="0" rtlCol="0" anchor="t"/>
-          <a:lstStyle/>
-          <a:p>
-            <a:pPr indent="0" marL="0">
-              <a:buNone/>
-            </a:pPr>
-            <a:r>
-              <a:rPr lang="en-US" sz="1400" i="1" dirty="0">
-                <a:solidFill>
-                  <a:schemeClr val="accent5"/>
-                </a:solidFill>
-              </a:rPr>
-              <a:t>The symbolic step does most of the reasoning; the learned model adds a little on top.</a:t>
-            </a:r>
-            <a:endParaRPr lang="en-US" sz="1400" dirty="0"/>
-          </a:p>
-        </p:txBody>
-      </p:sp>
-      <p:sp>
-        <p:nvSpPr>
-          <p:cNvPr id="25" name="Slide Number Placeholder 0"/>
-          <p:cNvSpPr>
-            <a:spLocks noGrp="1"/>
-          </p:cNvSpPr>
-          <p:nvPr>
-            <p:ph type="sldNum" sz="quarter" idx="4294967295"/>
-          </p:nvPr>
-        </p:nvSpPr>
-        <p:spPr>
-          <a:xfrm>
-            <a:off x="8229600" y="4754880"/>
-            <a:ext cx="457200" cy="228600"/>
-          </a:xfrm>
-          <a:prstGeom prst="rect">
-            <a:avLst/>
-          </a:prstGeom>
-          <a:extLst>
-            <a:ext uri="{C572A759-6A51-4108-AA02-DFA0A04FC94B}">
-              <ma14:wrappingTextBoxFlag xmlns:ma14="http://schemas.microsoft.com/office/mac/drawingml/2011/main" val="0"/>
-            </a:ext>
-          </a:extLst>
-        </p:spPr>
-        <p:txBody>
-          <a:bodyPr/>
-          <a:lstStyle>
-            <a:lvl1pPr>
-              <a:defRPr sz="900">
-                <a:solidFill>
-                  <a:schemeClr val="accent3"/>
-                </a:solidFill>
-              </a:defRPr>
-            </a:lvl1pPr>
-          </a:lstStyle>
-          <a:p>
-            <a:pPr algn="r"/>
-            <a:fld id="{F7021451-1387-4CA6-816F-3879F97B5CBC}" type="slidenum">
-              <a:rPr b="0" lang="en-US"/>
-              <a:t>4</a:t>
             </a:fld>
             <a:endParaRPr lang="en-US"/>
           </a:p>

</xml_diff>

<commit_message>
make conclusion slide clearer with one point per notebook and limitations
</commit_message>
<xml_diff>
--- a/report/phase1_presentation.pptx
+++ b/report/phase1_presentation.pptx
@@ -1784,7 +1784,7 @@
           <a:p>
             <a:r>
               <a:rPr lang="en-US" dirty="0"/>
-              <a:t>Presenter: Dhanvin or Jagruthi. Three takeaways, then limitations and the Phase 2 plan. Then open for questions.</a:t>
+              <a:t>Presenter: Jagruthi. One line per notebook: 01 cleaning and EDA, 02 parser and PC, 03 features, 04 models, 05 DAG and Bayesian network. Then the honest limits: the Bayesian network part only gives probabilities on data we simulated, because Corr2Cause is text with no numbers; it only runs on the 5 test premises where PC finds one graph; the regex parser depends on the fixed templates; train has only 5 to 6 variable graphs and some labels are noisy. Phase 2: a fine-tuned transformer reads reworded text while PC keeps the reasoning, tests on reworded and renamed-variable data, and checking the Bayesian network on real numeric data with an effect range when several DAGs fit. Then open for questions.</a:t>
             </a:r>
             <a:endParaRPr lang="en-US" dirty="0"/>
           </a:p>
@@ -8931,7 +8931,7 @@
                   <a:schemeClr val="bg1"/>
                 </a:solidFill>
               </a:rPr>
-              <a:t>What we showed, and what comes next</a:t>
+              <a:t>Summary, limitations and next steps</a:t>
             </a:r>
             <a:endParaRPr lang="en-US" sz="3000" dirty="0"/>
           </a:p>
@@ -8939,14 +8939,14 @@
       </p:sp>
       <p:sp>
         <p:nvSpPr>
-          <p:cNvPr id="3" name="node-126"/>
-          <p:cNvSpPr txBox="1"/>
-          <p:nvPr/>
-        </p:nvSpPr>
-        <p:spPr>
-          <a:xfrm>
-            <a:off x="502920" y="1234440"/>
-            <a:ext cx="457200" cy="457200"/>
+          <p:cNvPr id="21" name="node-21"/>
+          <p:cNvSpPr/>
+          <p:nvPr/>
+        </p:nvSpPr>
+        <p:spPr>
+          <a:xfrm>
+            <a:off x="457200" y="1133856"/>
+            <a:ext cx="365760" cy="365760"/>
           </a:xfrm>
           <a:prstGeom prst="ellipse">
             <a:avLst/>
@@ -8955,40 +8955,37 @@
             <a:schemeClr val="accent1"/>
           </a:solidFill>
           <a:ln>
-            <a:solidFill>
-              <a:schemeClr val="accent1"/>
-            </a:solidFill>
+            <a:noFill/>
           </a:ln>
         </p:spPr>
         <p:txBody>
-          <a:bodyPr wrap="square" lIns="0" tIns="0" rIns="0" bIns="0" rtlCol="0" anchor="ctr"/>
+          <a:bodyPr wrap="none" lIns="0" tIns="0" rIns="0" bIns="0" rtlCol="0" anchor="ctr"/>
           <a:lstStyle/>
           <a:p>
             <a:pPr algn="ctr" indent="0" marL="0">
               <a:buNone/>
             </a:pPr>
             <a:r>
-              <a:rPr lang="en-US" sz="1400" b="1" dirty="0">
+              <a:rPr lang="en-US" sz="1100" b="1" dirty="0">
                 <a:solidFill>
                   <a:schemeClr val="bg1"/>
                 </a:solidFill>
               </a:rPr>
-              <a:t>1</a:t>
-            </a:r>
-            <a:endParaRPr lang="en-US" sz="1400" dirty="0"/>
-          </a:p>
-        </p:txBody>
-      </p:sp>
-      <p:sp>
-        <p:nvSpPr>
-          <p:cNvPr id="4" name="text-127"/>
+              <a:t>01</a:t>
+            </a:r>
+          </a:p>
+        </p:txBody>
+      </p:sp>
+      <p:sp>
+        <p:nvSpPr>
+          <p:cNvPr id="22" name="text-22"/>
           <p:cNvSpPr txBox="1"/>
           <p:nvPr/>
         </p:nvSpPr>
         <p:spPr>
           <a:xfrm>
-            <a:off x="1143000" y="1120140"/>
-            <a:ext cx="3931920" cy="685800"/>
+            <a:off x="960120" y="1097280"/>
+            <a:ext cx="3703320" cy="548640"/>
           </a:xfrm>
           <a:prstGeom prst="rect">
             <a:avLst/>
@@ -8997,34 +8994,46 @@
           <a:ln/>
         </p:spPr>
         <p:txBody>
-          <a:bodyPr wrap="square" lIns="0" tIns="0" rIns="0" bIns="0" rtlCol="0" anchor="ctr"/>
-          <a:lstStyle/>
-          <a:p>
-            <a:pPr indent="0" marL="0">
-              <a:buNone/>
-            </a:pPr>
-            <a:r>
-              <a:rPr lang="en-US" sz="1300" dirty="0">
+          <a:bodyPr wrap="square" lIns="0" tIns="0" rIns="0" bIns="0" rtlCol="0" anchor="t"/>
+          <a:lstStyle/>
+          <a:p>
+            <a:pPr algn="l" indent="0" marL="0">
+              <a:buNone/>
+            </a:pPr>
+            <a:r>
+              <a:rPr lang="en-US" sz="1200" b="1" dirty="0">
                 <a:solidFill>
                   <a:schemeClr val="bg1"/>
                 </a:solidFill>
               </a:rPr>
-              <a:t>Text features alone reach only 0.47 F1. Formal causal reasoning cannot be replaced by word counts.</a:t>
-            </a:r>
-            <a:endParaRPr lang="en-US" sz="1300" dirty="0"/>
-          </a:p>
-        </p:txBody>
-      </p:sp>
-      <p:sp>
-        <p:nvSpPr>
-          <p:cNvPr id="5" name="node-128"/>
-          <p:cNvSpPr txBox="1"/>
-          <p:nvPr/>
-        </p:nvSpPr>
-        <p:spPr>
-          <a:xfrm>
-            <a:off x="502920" y="2011680"/>
-            <a:ext cx="457200" cy="457200"/>
+              <a:t>Input and EDA</a:t>
+            </a:r>
+          </a:p>
+          <a:p>
+            <a:pPr algn="l" indent="0" marL="0">
+              <a:buNone/>
+            </a:pPr>
+            <a:r>
+              <a:rPr lang="en-US" sz="1050" dirty="0">
+                <a:solidFill>
+                  <a:schemeClr val="bg2"/>
+                </a:solidFill>
+              </a:rPr>
+              <a:t>Clean splits, no premise leakage. Only 13–19% of claims are valid, so we use F1 and class weights.</a:t>
+            </a:r>
+          </a:p>
+        </p:txBody>
+      </p:sp>
+      <p:sp>
+        <p:nvSpPr>
+          <p:cNvPr id="23" name="node-23"/>
+          <p:cNvSpPr/>
+          <p:nvPr/>
+        </p:nvSpPr>
+        <p:spPr>
+          <a:xfrm>
+            <a:off x="457200" y="1737360"/>
+            <a:ext cx="365760" cy="365760"/>
           </a:xfrm>
           <a:prstGeom prst="ellipse">
             <a:avLst/>
@@ -9033,40 +9042,37 @@
             <a:schemeClr val="accent1"/>
           </a:solidFill>
           <a:ln>
-            <a:solidFill>
-              <a:schemeClr val="accent1"/>
-            </a:solidFill>
+            <a:noFill/>
           </a:ln>
         </p:spPr>
         <p:txBody>
-          <a:bodyPr wrap="square" lIns="0" tIns="0" rIns="0" bIns="0" rtlCol="0" anchor="ctr"/>
+          <a:bodyPr wrap="none" lIns="0" tIns="0" rIns="0" bIns="0" rtlCol="0" anchor="ctr"/>
           <a:lstStyle/>
           <a:p>
             <a:pPr algn="ctr" indent="0" marL="0">
               <a:buNone/>
             </a:pPr>
             <a:r>
-              <a:rPr lang="en-US" sz="1400" b="1" dirty="0">
+              <a:rPr lang="en-US" sz="1100" b="1" dirty="0">
                 <a:solidFill>
                   <a:schemeClr val="bg1"/>
                 </a:solidFill>
               </a:rPr>
-              <a:t>2</a:t>
-            </a:r>
-            <a:endParaRPr lang="en-US" sz="1400" dirty="0"/>
-          </a:p>
-        </p:txBody>
-      </p:sp>
-      <p:sp>
-        <p:nvSpPr>
-          <p:cNvPr id="6" name="text-129"/>
+              <a:t>02</a:t>
+            </a:r>
+          </a:p>
+        </p:txBody>
+      </p:sp>
+      <p:sp>
+        <p:nvSpPr>
+          <p:cNvPr id="24" name="text-24"/>
           <p:cNvSpPr txBox="1"/>
           <p:nvPr/>
         </p:nvSpPr>
         <p:spPr>
           <a:xfrm>
-            <a:off x="1143000" y="1897380"/>
-            <a:ext cx="3931920" cy="685800"/>
+            <a:off x="960120" y="1700784"/>
+            <a:ext cx="3703320" cy="548640"/>
           </a:xfrm>
           <a:prstGeom prst="rect">
             <a:avLst/>
@@ -9075,34 +9081,46 @@
           <a:ln/>
         </p:spPr>
         <p:txBody>
-          <a:bodyPr wrap="square" lIns="0" tIns="0" rIns="0" bIns="0" rtlCol="0" anchor="ctr"/>
-          <a:lstStyle/>
-          <a:p>
-            <a:pPr indent="0" marL="0">
-              <a:buNone/>
-            </a:pPr>
-            <a:r>
-              <a:rPr lang="en-US" sz="1300" dirty="0">
+          <a:bodyPr wrap="square" lIns="0" tIns="0" rIns="0" bIns="0" rtlCol="0" anchor="t"/>
+          <a:lstStyle/>
+          <a:p>
+            <a:pPr algn="l" indent="0" marL="0">
+              <a:buNone/>
+            </a:pPr>
+            <a:r>
+              <a:rPr lang="en-US" sz="1200" b="1" dirty="0">
                 <a:solidFill>
                   <a:schemeClr val="bg1"/>
                 </a:solidFill>
               </a:rPr>
-              <a:t>Parser + PC with the generator's definitions explain 98.5% of test labels; the model reaches 0.957 F1.</a:t>
-            </a:r>
-            <a:endParaRPr lang="en-US" sz="1300" dirty="0"/>
-          </a:p>
-        </p:txBody>
-      </p:sp>
-      <p:sp>
-        <p:nvSpPr>
-          <p:cNvPr id="7" name="node-130"/>
-          <p:cNvSpPr txBox="1"/>
-          <p:nvPr/>
-        </p:nvSpPr>
-        <p:spPr>
-          <a:xfrm>
-            <a:off x="502920" y="2788920"/>
-            <a:ext cx="457200" cy="457200"/>
+              <a:t>Parsing and PC</a:t>
+            </a:r>
+          </a:p>
+          <a:p>
+            <a:pPr algn="l" indent="0" marL="0">
+              <a:buNone/>
+            </a:pPr>
+            <a:r>
+              <a:rPr lang="en-US" sz="1050" dirty="0">
+                <a:solidFill>
+                  <a:schemeClr val="bg2"/>
+                </a:solidFill>
+              </a:rPr>
+              <a:t>Regex reads the text, PC builds the graph: 98.5% of test labels explained with no learning.</a:t>
+            </a:r>
+          </a:p>
+        </p:txBody>
+      </p:sp>
+      <p:sp>
+        <p:nvSpPr>
+          <p:cNvPr id="25" name="node-25"/>
+          <p:cNvSpPr/>
+          <p:nvPr/>
+        </p:nvSpPr>
+        <p:spPr>
+          <a:xfrm>
+            <a:off x="457200" y="2340864"/>
+            <a:ext cx="365760" cy="365760"/>
           </a:xfrm>
           <a:prstGeom prst="ellipse">
             <a:avLst/>
@@ -9111,40 +9129,37 @@
             <a:schemeClr val="accent1"/>
           </a:solidFill>
           <a:ln>
-            <a:solidFill>
-              <a:schemeClr val="accent1"/>
-            </a:solidFill>
+            <a:noFill/>
           </a:ln>
         </p:spPr>
         <p:txBody>
-          <a:bodyPr wrap="square" lIns="0" tIns="0" rIns="0" bIns="0" rtlCol="0" anchor="ctr"/>
+          <a:bodyPr wrap="none" lIns="0" tIns="0" rIns="0" bIns="0" rtlCol="0" anchor="ctr"/>
           <a:lstStyle/>
           <a:p>
             <a:pPr algn="ctr" indent="0" marL="0">
               <a:buNone/>
             </a:pPr>
             <a:r>
-              <a:rPr lang="en-US" sz="1400" b="1" dirty="0">
+              <a:rPr lang="en-US" sz="1100" b="1" dirty="0">
                 <a:solidFill>
                   <a:schemeClr val="bg1"/>
                 </a:solidFill>
               </a:rPr>
-              <a:t>3</a:t>
-            </a:r>
-            <a:endParaRPr lang="en-US" sz="1400" dirty="0"/>
-          </a:p>
-        </p:txBody>
-      </p:sp>
-      <p:sp>
-        <p:nvSpPr>
-          <p:cNvPr id="8" name="text-131"/>
+              <a:t>03</a:t>
+            </a:r>
+          </a:p>
+        </p:txBody>
+      </p:sp>
+      <p:sp>
+        <p:nvSpPr>
+          <p:cNvPr id="26" name="text-26"/>
           <p:cNvSpPr txBox="1"/>
           <p:nvPr/>
         </p:nvSpPr>
         <p:spPr>
           <a:xfrm>
-            <a:off x="1143000" y="2674620"/>
-            <a:ext cx="3931920" cy="685800"/>
+            <a:off x="960120" y="2304288"/>
+            <a:ext cx="3703320" cy="548640"/>
           </a:xfrm>
           <a:prstGeom prst="rect">
             <a:avLst/>
@@ -9153,34 +9168,85 @@
           <a:ln/>
         </p:spPr>
         <p:txBody>
-          <a:bodyPr wrap="square" lIns="0" tIns="0" rIns="0" bIns="0" rtlCol="0" anchor="ctr"/>
-          <a:lstStyle/>
-          <a:p>
-            <a:pPr indent="0" marL="0">
-              <a:buNone/>
-            </a:pPr>
-            <a:r>
-              <a:rPr lang="en-US" sz="1300" dirty="0">
+          <a:bodyPr wrap="square" lIns="0" tIns="0" rIns="0" bIns="0" rtlCol="0" anchor="t"/>
+          <a:lstStyle/>
+          <a:p>
+            <a:pPr algn="l" indent="0" marL="0">
+              <a:buNone/>
+            </a:pPr>
+            <a:r>
+              <a:rPr lang="en-US" sz="1200" b="1" dirty="0">
                 <a:solidFill>
                   <a:schemeClr val="bg1"/>
                 </a:solidFill>
               </a:rPr>
-              <a:t>Correct arrows give correct what-if answers: 28 of 32 real effects, against 0 for the baselines.</a:t>
-            </a:r>
-            <a:endParaRPr lang="en-US" sz="1300" dirty="0"/>
-          </a:p>
-        </p:txBody>
-      </p:sp>
-      <p:sp>
-        <p:nvSpPr>
-          <p:cNvPr id="9" name="text-132"/>
+              <a:t>Feature engineering</a:t>
+            </a:r>
+          </a:p>
+          <a:p>
+            <a:pPr algn="l" indent="0" marL="0">
+              <a:buNone/>
+            </a:pPr>
+            <a:r>
+              <a:rPr lang="en-US" sz="1050" dirty="0">
+                <a:solidFill>
+                  <a:schemeClr val="bg2"/>
+                </a:solidFill>
+              </a:rPr>
+              <a:t>TF-IDF alone gets F1 0.47. Adding the graph features raises it to 0.88.</a:t>
+            </a:r>
+          </a:p>
+        </p:txBody>
+      </p:sp>
+      <p:sp>
+        <p:nvSpPr>
+          <p:cNvPr id="27" name="node-27"/>
+          <p:cNvSpPr/>
+          <p:nvPr/>
+        </p:nvSpPr>
+        <p:spPr>
+          <a:xfrm>
+            <a:off x="457200" y="2944368"/>
+            <a:ext cx="365760" cy="365760"/>
+          </a:xfrm>
+          <a:prstGeom prst="ellipse">
+            <a:avLst/>
+          </a:prstGeom>
+          <a:solidFill>
+            <a:schemeClr val="accent1"/>
+          </a:solidFill>
+          <a:ln>
+            <a:noFill/>
+          </a:ln>
+        </p:spPr>
+        <p:txBody>
+          <a:bodyPr wrap="none" lIns="0" tIns="0" rIns="0" bIns="0" rtlCol="0" anchor="ctr"/>
+          <a:lstStyle/>
+          <a:p>
+            <a:pPr algn="ctr" indent="0" marL="0">
+              <a:buNone/>
+            </a:pPr>
+            <a:r>
+              <a:rPr lang="en-US" sz="1100" b="1" dirty="0">
+                <a:solidFill>
+                  <a:schemeClr val="bg1"/>
+                </a:solidFill>
+              </a:rPr>
+              <a:t>04</a:t>
+            </a:r>
+          </a:p>
+        </p:txBody>
+      </p:sp>
+      <p:sp>
+        <p:nvSpPr>
+          <p:cNvPr id="28" name="text-28"/>
           <p:cNvSpPr txBox="1"/>
           <p:nvPr/>
         </p:nvSpPr>
         <p:spPr>
           <a:xfrm>
-            <a:off x="5486400" y="1234440"/>
-            <a:ext cx="3200400" cy="1371600"/>
+            <a:off x="960120" y="2907792"/>
+            <a:ext cx="3703320" cy="548640"/>
           </a:xfrm>
           <a:prstGeom prst="rect">
             <a:avLst/>
@@ -9192,45 +9258,82 @@
           <a:bodyPr wrap="square" lIns="0" tIns="0" rIns="0" bIns="0" rtlCol="0" anchor="t"/>
           <a:lstStyle/>
           <a:p>
-            <a:pPr indent="0" marL="0">
-              <a:buNone/>
-            </a:pPr>
-            <a:r>
-              <a:rPr lang="en-US" sz="1400" b="1" dirty="0">
-                <a:solidFill>
-                  <a:schemeClr val="accent6"/>
-                </a:solidFill>
-              </a:rPr>
-              <a:t>Limitations</a:t>
-            </a:r>
-            <a:endParaRPr lang="en-US" sz="1400" dirty="0"/>
-          </a:p>
-          <a:p>
-            <a:pPr indent="0" marL="0">
-              <a:buNone/>
-            </a:pPr>
-            <a:r>
-              <a:rPr lang="en-US" sz="1300" dirty="0">
+            <a:pPr algn="l" indent="0" marL="0">
+              <a:buNone/>
+            </a:pPr>
+            <a:r>
+              <a:rPr lang="en-US" sz="1200" b="1" dirty="0">
                 <a:solidFill>
                   <a:schemeClr val="bg1"/>
                 </a:solidFill>
               </a:rPr>
-              <a:t>Templated text and letters in causal order; train has only 5–6 variable graphs; Bayesian network data is simulated.</a:t>
-            </a:r>
-            <a:endParaRPr lang="en-US" sz="1400" dirty="0"/>
-          </a:p>
-        </p:txBody>
-      </p:sp>
-      <p:sp>
-        <p:nvSpPr>
-          <p:cNvPr id="10" name="text-133"/>
+              <a:t>Models and evaluation</a:t>
+            </a:r>
+          </a:p>
+          <a:p>
+            <a:pPr algn="l" indent="0" marL="0">
+              <a:buNone/>
+            </a:pPr>
+            <a:r>
+              <a:rPr lang="en-US" sz="1050" dirty="0">
+                <a:solidFill>
+                  <a:schemeClr val="bg2"/>
+                </a:solidFill>
+              </a:rPr>
+              <a:t>Random Forest, chosen on validation: test F1 0.957, with a 95% CI of 0.921 to 0.982.</a:t>
+            </a:r>
+          </a:p>
+        </p:txBody>
+      </p:sp>
+      <p:sp>
+        <p:nvSpPr>
+          <p:cNvPr id="29" name="node-29"/>
+          <p:cNvSpPr/>
+          <p:nvPr/>
+        </p:nvSpPr>
+        <p:spPr>
+          <a:xfrm>
+            <a:off x="457200" y="3547872"/>
+            <a:ext cx="365760" cy="365760"/>
+          </a:xfrm>
+          <a:prstGeom prst="ellipse">
+            <a:avLst/>
+          </a:prstGeom>
+          <a:solidFill>
+            <a:schemeClr val="accent1"/>
+          </a:solidFill>
+          <a:ln>
+            <a:noFill/>
+          </a:ln>
+        </p:spPr>
+        <p:txBody>
+          <a:bodyPr wrap="none" lIns="0" tIns="0" rIns="0" bIns="0" rtlCol="0" anchor="ctr"/>
+          <a:lstStyle/>
+          <a:p>
+            <a:pPr algn="ctr" indent="0" marL="0">
+              <a:buNone/>
+            </a:pPr>
+            <a:r>
+              <a:rPr lang="en-US" sz="1100" b="1" dirty="0">
+                <a:solidFill>
+                  <a:schemeClr val="bg1"/>
+                </a:solidFill>
+              </a:rPr>
+              <a:t>05</a:t>
+            </a:r>
+          </a:p>
+        </p:txBody>
+      </p:sp>
+      <p:sp>
+        <p:nvSpPr>
+          <p:cNvPr id="30" name="text-30"/>
           <p:cNvSpPr txBox="1"/>
           <p:nvPr/>
         </p:nvSpPr>
         <p:spPr>
           <a:xfrm>
-            <a:off x="5486400" y="2514600"/>
-            <a:ext cx="3200400" cy="1371600"/>
+            <a:off x="960120" y="3511296"/>
+            <a:ext cx="3703320" cy="548640"/>
           </a:xfrm>
           <a:prstGeom prst="rect">
             <a:avLst/>
@@ -9242,32 +9345,246 @@
           <a:bodyPr wrap="square" lIns="0" tIns="0" rIns="0" bIns="0" rtlCol="0" anchor="t"/>
           <a:lstStyle/>
           <a:p>
-            <a:pPr indent="0" marL="0">
-              <a:buNone/>
-            </a:pPr>
-            <a:r>
-              <a:rPr lang="en-US" sz="1400" b="1" dirty="0">
+            <a:pPr algn="l" indent="0" marL="0">
+              <a:buNone/>
+            </a:pPr>
+            <a:r>
+              <a:rPr lang="en-US" sz="1200" b="1" dirty="0">
+                <a:solidFill>
+                  <a:schemeClr val="bg1"/>
+                </a:solidFill>
+              </a:rPr>
+              <a:t>DAG and Bayesian network</a:t>
+            </a:r>
+          </a:p>
+          <a:p>
+            <a:pPr algn="l" indent="0" marL="0">
+              <a:buNone/>
+            </a:pPr>
+            <a:r>
+              <a:rPr lang="en-US" sz="1050" dirty="0">
+                <a:solidFill>
+                  <a:schemeClr val="bg2"/>
+                </a:solidFill>
+              </a:rPr>
+              <a:t>Edge precision 0.89, no cycles. 28 of 32 real what-if effects answered correctly.</a:t>
+            </a:r>
+          </a:p>
+        </p:txBody>
+      </p:sp>
+      <p:sp>
+        <p:nvSpPr>
+          <p:cNvPr id="31" name="text-31"/>
+          <p:cNvSpPr txBox="1"/>
+          <p:nvPr/>
+        </p:nvSpPr>
+        <p:spPr>
+          <a:xfrm>
+            <a:off x="4983480" y="1051560"/>
+            <a:ext cx="3703320" cy="1920240"/>
+          </a:xfrm>
+          <a:prstGeom prst="rect">
+            <a:avLst/>
+          </a:prstGeom>
+          <a:noFill/>
+          <a:ln/>
+        </p:spPr>
+        <p:txBody>
+          <a:bodyPr wrap="square" lIns="0" tIns="0" rIns="0" bIns="0" rtlCol="0" anchor="t"/>
+          <a:lstStyle/>
+          <a:p>
+            <a:pPr algn="l" indent="0" marL="0">
+              <a:spcAft>
+                <a:spcPts val="300"/>
+              </a:spcAft>
+              <a:buNone/>
+            </a:pPr>
+            <a:r>
+              <a:rPr lang="en-US" sz="1300" b="1" dirty="0">
                 <a:solidFill>
                   <a:schemeClr val="accent6"/>
                 </a:solidFill>
               </a:rPr>
-              <a:t>Phase 2</a:t>
-            </a:r>
-            <a:endParaRPr lang="en-US" sz="1400" dirty="0"/>
-          </a:p>
-          <a:p>
-            <a:pPr indent="0" marL="0">
-              <a:buNone/>
-            </a:pPr>
-            <a:r>
-              <a:rPr lang="en-US" sz="1300" dirty="0">
+              <a:t>Limitations right now</a:t>
+            </a:r>
+          </a:p>
+          <a:p>
+            <a:pPr marL="171450" indent="-171450">
+              <a:spcAft>
+                <a:spcPts val="300"/>
+              </a:spcAft>
+              <a:buClr>
+                <a:schemeClr val="accent1"/>
+              </a:buClr>
+              <a:buSzPct val="100000"/>
+              <a:buChar char="•"/>
+            </a:pPr>
+            <a:r>
+              <a:rPr lang="en-US" sz="1050" dirty="0">
                 <a:solidFill>
                   <a:schemeClr val="bg1"/>
                 </a:solidFill>
               </a:rPr>
-              <a:t>A fine-tuned transformer reads paraphrased text, PC keeps the reasoning, tested on reworded and renamed-variable data.</a:t>
-            </a:r>
-            <a:endParaRPr lang="en-US" sz="1400" dirty="0"/>
+              <a:t>The Bayesian network only gives probabilities on simulated data: Corr2Cause has no numbers, so we made random probability tables.</a:t>
+            </a:r>
+          </a:p>
+          <a:p>
+            <a:pPr marL="171450" indent="-171450">
+              <a:spcAft>
+                <a:spcPts val="300"/>
+              </a:spcAft>
+              <a:buClr>
+                <a:schemeClr val="accent1"/>
+              </a:buClr>
+              <a:buSzPct val="100000"/>
+              <a:buChar char="•"/>
+            </a:pPr>
+            <a:r>
+              <a:rPr lang="en-US" sz="1050" dirty="0">
+                <a:solidFill>
+                  <a:schemeClr val="bg1"/>
+                </a:solidFill>
+              </a:rPr>
+              <a:t>The what-if check only works when PC finds exactly one graph: 5 of the 21 test premises.</a:t>
+            </a:r>
+          </a:p>
+          <a:p>
+            <a:pPr marL="171450" indent="-171450">
+              <a:spcAft>
+                <a:spcPts val="300"/>
+              </a:spcAft>
+              <a:buClr>
+                <a:schemeClr val="accent1"/>
+              </a:buClr>
+              <a:buSzPct val="100000"/>
+              <a:buChar char="•"/>
+            </a:pPr>
+            <a:r>
+              <a:rPr lang="en-US" sz="1050" dirty="0">
+                <a:solidFill>
+                  <a:schemeClr val="bg1"/>
+                </a:solidFill>
+              </a:rPr>
+              <a:t>The regex parser only reads Corr2Cause's fixed sentences. Reworded text would break it.</a:t>
+            </a:r>
+          </a:p>
+          <a:p>
+            <a:pPr marL="171450" indent="-171450">
+              <a:spcAft>
+                <a:spcPts val="300"/>
+              </a:spcAft>
+              <a:buClr>
+                <a:schemeClr val="accent1"/>
+              </a:buClr>
+              <a:buSzPct val="100000"/>
+              <a:buChar char="•"/>
+            </a:pPr>
+            <a:r>
+              <a:rPr lang="en-US" sz="1050" dirty="0">
+                <a:solidFill>
+                  <a:schemeClr val="bg1"/>
+                </a:solidFill>
+              </a:rPr>
+              <a:t>Train has only 5–6 variable graphs, and some labels disagree with PC (label noise).</a:t>
+            </a:r>
+          </a:p>
+        </p:txBody>
+      </p:sp>
+      <p:sp>
+        <p:nvSpPr>
+          <p:cNvPr id="32" name="text-32"/>
+          <p:cNvSpPr txBox="1"/>
+          <p:nvPr/>
+        </p:nvSpPr>
+        <p:spPr>
+          <a:xfrm>
+            <a:off x="4983480" y="3108960"/>
+            <a:ext cx="3703320" cy="1325880"/>
+          </a:xfrm>
+          <a:prstGeom prst="rect">
+            <a:avLst/>
+          </a:prstGeom>
+          <a:noFill/>
+          <a:ln/>
+        </p:spPr>
+        <p:txBody>
+          <a:bodyPr wrap="square" lIns="0" tIns="0" rIns="0" bIns="0" rtlCol="0" anchor="t"/>
+          <a:lstStyle/>
+          <a:p>
+            <a:pPr algn="l" indent="0" marL="0">
+              <a:spcAft>
+                <a:spcPts val="300"/>
+              </a:spcAft>
+              <a:buNone/>
+            </a:pPr>
+            <a:r>
+              <a:rPr lang="en-US" sz="1300" b="1" dirty="0">
+                <a:solidFill>
+                  <a:schemeClr val="accent6"/>
+                </a:solidFill>
+              </a:rPr>
+              <a:t>What we will fix next (Phase 2)</a:t>
+            </a:r>
+          </a:p>
+          <a:p>
+            <a:pPr marL="171450" indent="-171450">
+              <a:spcAft>
+                <a:spcPts val="300"/>
+              </a:spcAft>
+              <a:buClr>
+                <a:schemeClr val="accent1"/>
+              </a:buClr>
+              <a:buSzPct val="100000"/>
+              <a:buChar char="•"/>
+            </a:pPr>
+            <a:r>
+              <a:rPr lang="en-US" sz="1050" dirty="0">
+                <a:solidFill>
+                  <a:schemeClr val="bg1"/>
+                </a:solidFill>
+              </a:rPr>
+              <a:t>Replace regex and TF-IDF with a fine-tuned transformer that reads reworded text. PC still does the reasoning.</a:t>
+            </a:r>
+          </a:p>
+          <a:p>
+            <a:pPr marL="171450" indent="-171450">
+              <a:spcAft>
+                <a:spcPts val="300"/>
+              </a:spcAft>
+              <a:buClr>
+                <a:schemeClr val="accent1"/>
+              </a:buClr>
+              <a:buSzPct val="100000"/>
+              <a:buChar char="•"/>
+            </a:pPr>
+            <a:r>
+              <a:rPr lang="en-US" sz="1050" dirty="0">
+                <a:solidFill>
+                  <a:schemeClr val="bg1"/>
+                </a:solidFill>
+              </a:rPr>
+              <a:t>Test on reworded and renamed-variable versions of the data.</a:t>
+            </a:r>
+          </a:p>
+          <a:p>
+            <a:pPr marL="171450" indent="-171450">
+              <a:spcAft>
+                <a:spcPts val="300"/>
+              </a:spcAft>
+              <a:buClr>
+                <a:schemeClr val="accent1"/>
+              </a:buClr>
+              <a:buSzPct val="100000"/>
+              <a:buChar char="•"/>
+            </a:pPr>
+            <a:r>
+              <a:rPr lang="en-US" sz="1050" dirty="0">
+                <a:solidFill>
+                  <a:schemeClr val="bg1"/>
+                </a:solidFill>
+              </a:rPr>
+              <a:t>Check the Bayesian network on real numeric data, and give a range of effects over all fitting DAGs when the graph is not unique.</a:t>
+            </a:r>
           </a:p>
         </p:txBody>
       </p:sp>

</xml_diff>